<commit_message>
Improve executive edition: RTL tables, charts, English school name.
Use Lord School in English only, fix the phase/actions table for RTL,
and add occupancy, year-1 phases, and five-year roadmap charts.

Co-authored-by: waseemabdelbaqi-lgtm <waseemabdelbaqi-lgtm@users.noreply.github.com>
</commit_message>
<xml_diff>
--- a/executive-edition/output/Lord_International_Program_Development_Plan_Executive.pptx
+++ b/executive-edition/output/Lord_International_Program_Development_Plan_Executive.pptx
@@ -14,6 +14,7 @@
     <p:sldId id="262" r:id="rId13"/>
     <p:sldId id="263" r:id="rId14"/>
     <p:sldId id="264" r:id="rId15"/>
+    <p:sldId id="265" r:id="rId16"/>
   </p:sldIdLst>
   <p:sldSz cx="9144000" cy="6858000" type="screen4x3"/>
   <p:notesSz cx="6858000" cy="9144000"/>
@@ -3556,15 +3557,15 @@
           </a:bodyPr>
           <a:lstStyle/>
           <a:p>
-            <a:pPr algn="ctr" rtl="1"/>
-            <a:r>
-              <a:rPr sz="3200" b="1">
+            <a:pPr algn="ctr"/>
+            <a:r>
+              <a:rPr sz="3400" b="1">
                 <a:solidFill>
                   <a:srgbClr val="8B1E2D"/>
                 </a:solidFill>
-                <a:latin typeface="Amiri"/>
+                <a:latin typeface="Liberation Serif"/>
               </a:rPr>
-              <a:t>مدرسة اللورد</a:t>
+              <a:t>Lord School</a:t>
             </a:r>
           </a:p>
         </p:txBody>
@@ -3775,6 +3776,724 @@
                 <a:latin typeface="Amiri"/>
               </a:rPr>
               <a:t>وثيقة عمل أولية مبنية على المعلومات التقديرية والملاحظات الميدانية المتاحة</a:t>
+            </a:r>
+          </a:p>
+        </p:txBody>
+      </p:sp>
+    </p:spTree>
+  </p:cSld>
+  <p:clrMapOvr>
+    <a:masterClrMapping/>
+  </p:clrMapOvr>
+</p:sld>
+</file>
+
+<file path=ppt/slides/slide10.xml><?xml version="1.0" encoding="utf-8"?>
+<p:sld xmlns:a="http://schemas.openxmlformats.org/drawingml/2006/main" xmlns:p="http://schemas.openxmlformats.org/presentationml/2006/main" xmlns:r="http://schemas.openxmlformats.org/officeDocument/2006/relationships">
+  <p:cSld>
+    <p:spTree>
+      <p:nvGrpSpPr>
+        <p:cNvPr id="1" name=""/>
+        <p:cNvGrpSpPr/>
+        <p:nvPr/>
+      </p:nvGrpSpPr>
+      <p:grpSpPr/>
+      <p:pic>
+        <p:nvPicPr>
+          <p:cNvPr id="10" name="Picture 9" descr="success4sure_watermark.png"/>
+          <p:cNvPicPr>
+            <a:picLocks noChangeAspect="1"/>
+          </p:cNvPicPr>
+          <p:nvPr/>
+        </p:nvPicPr>
+        <p:blipFill>
+          <a:blip r:embed="rId2"/>
+          <a:stretch>
+            <a:fillRect/>
+          </a:stretch>
+        </p:blipFill>
+        <p:spPr>
+          <a:xfrm>
+            <a:off x="1463040" y="2194560"/>
+            <a:ext cx="6400800" cy="4586400"/>
+          </a:xfrm>
+          <a:prstGeom prst="rect">
+            <a:avLst/>
+          </a:prstGeom>
+        </p:spPr>
+      </p:pic>
+      <p:sp>
+        <p:nvSpPr>
+          <p:cNvPr id="2" name="Rectangle 1"/>
+          <p:cNvSpPr/>
+          <p:nvPr/>
+        </p:nvSpPr>
+        <p:spPr>
+          <a:xfrm>
+            <a:off x="228600" y="228600"/>
+            <a:ext cx="8686800" cy="41148"/>
+          </a:xfrm>
+          <a:prstGeom prst="rect">
+            <a:avLst/>
+          </a:prstGeom>
+          <a:solidFill>
+            <a:srgbClr val="8B1E2D"/>
+          </a:solidFill>
+          <a:ln>
+            <a:noFill/>
+          </a:ln>
+        </p:spPr>
+        <p:style>
+          <a:lnRef idx="1">
+            <a:schemeClr val="accent1"/>
+          </a:lnRef>
+          <a:fillRef idx="3">
+            <a:schemeClr val="accent1"/>
+          </a:fillRef>
+          <a:effectRef idx="2">
+            <a:schemeClr val="accent1"/>
+          </a:effectRef>
+          <a:fontRef idx="minor">
+            <a:schemeClr val="lt1"/>
+          </a:fontRef>
+        </p:style>
+        <p:txBody>
+          <a:bodyPr rtlCol="0" anchor="ctr"/>
+          <a:lstStyle/>
+          <a:p>
+            <a:pPr algn="ctr"/>
+          </a:p>
+        </p:txBody>
+      </p:sp>
+      <p:sp>
+        <p:nvSpPr>
+          <p:cNvPr id="3" name="Rectangle 2"/>
+          <p:cNvSpPr/>
+          <p:nvPr/>
+        </p:nvSpPr>
+        <p:spPr>
+          <a:xfrm>
+            <a:off x="228600" y="6588252"/>
+            <a:ext cx="8686800" cy="41148"/>
+          </a:xfrm>
+          <a:prstGeom prst="rect">
+            <a:avLst/>
+          </a:prstGeom>
+          <a:solidFill>
+            <a:srgbClr val="8B1E2D"/>
+          </a:solidFill>
+          <a:ln>
+            <a:noFill/>
+          </a:ln>
+        </p:spPr>
+        <p:style>
+          <a:lnRef idx="1">
+            <a:schemeClr val="accent1"/>
+          </a:lnRef>
+          <a:fillRef idx="3">
+            <a:schemeClr val="accent1"/>
+          </a:fillRef>
+          <a:effectRef idx="2">
+            <a:schemeClr val="accent1"/>
+          </a:effectRef>
+          <a:fontRef idx="minor">
+            <a:schemeClr val="lt1"/>
+          </a:fontRef>
+        </p:style>
+        <p:txBody>
+          <a:bodyPr rtlCol="0" anchor="ctr"/>
+          <a:lstStyle/>
+          <a:p>
+            <a:pPr algn="ctr"/>
+          </a:p>
+        </p:txBody>
+      </p:sp>
+      <p:sp>
+        <p:nvSpPr>
+          <p:cNvPr id="4" name="Rectangle 3"/>
+          <p:cNvSpPr/>
+          <p:nvPr/>
+        </p:nvSpPr>
+        <p:spPr>
+          <a:xfrm>
+            <a:off x="228600" y="228600"/>
+            <a:ext cx="41148" cy="6400800"/>
+          </a:xfrm>
+          <a:prstGeom prst="rect">
+            <a:avLst/>
+          </a:prstGeom>
+          <a:solidFill>
+            <a:srgbClr val="8B1E2D"/>
+          </a:solidFill>
+          <a:ln>
+            <a:noFill/>
+          </a:ln>
+        </p:spPr>
+        <p:style>
+          <a:lnRef idx="1">
+            <a:schemeClr val="accent1"/>
+          </a:lnRef>
+          <a:fillRef idx="3">
+            <a:schemeClr val="accent1"/>
+          </a:fillRef>
+          <a:effectRef idx="2">
+            <a:schemeClr val="accent1"/>
+          </a:effectRef>
+          <a:fontRef idx="minor">
+            <a:schemeClr val="lt1"/>
+          </a:fontRef>
+        </p:style>
+        <p:txBody>
+          <a:bodyPr rtlCol="0" anchor="ctr"/>
+          <a:lstStyle/>
+          <a:p>
+            <a:pPr algn="ctr"/>
+          </a:p>
+        </p:txBody>
+      </p:sp>
+      <p:sp>
+        <p:nvSpPr>
+          <p:cNvPr id="5" name="Rectangle 4"/>
+          <p:cNvSpPr/>
+          <p:nvPr/>
+        </p:nvSpPr>
+        <p:spPr>
+          <a:xfrm>
+            <a:off x="8874252" y="228600"/>
+            <a:ext cx="41148" cy="6400800"/>
+          </a:xfrm>
+          <a:prstGeom prst="rect">
+            <a:avLst/>
+          </a:prstGeom>
+          <a:solidFill>
+            <a:srgbClr val="8B1E2D"/>
+          </a:solidFill>
+          <a:ln>
+            <a:noFill/>
+          </a:ln>
+        </p:spPr>
+        <p:style>
+          <a:lnRef idx="1">
+            <a:schemeClr val="accent1"/>
+          </a:lnRef>
+          <a:fillRef idx="3">
+            <a:schemeClr val="accent1"/>
+          </a:fillRef>
+          <a:effectRef idx="2">
+            <a:schemeClr val="accent1"/>
+          </a:effectRef>
+          <a:fontRef idx="minor">
+            <a:schemeClr val="lt1"/>
+          </a:fontRef>
+        </p:style>
+        <p:txBody>
+          <a:bodyPr rtlCol="0" anchor="ctr"/>
+          <a:lstStyle/>
+          <a:p>
+            <a:pPr algn="ctr"/>
+          </a:p>
+        </p:txBody>
+      </p:sp>
+      <p:sp>
+        <p:nvSpPr>
+          <p:cNvPr id="6" name="Rectangle 5"/>
+          <p:cNvSpPr/>
+          <p:nvPr/>
+        </p:nvSpPr>
+        <p:spPr>
+          <a:xfrm>
+            <a:off x="310896" y="310896"/>
+            <a:ext cx="8522208" cy="10972"/>
+          </a:xfrm>
+          <a:prstGeom prst="rect">
+            <a:avLst/>
+          </a:prstGeom>
+          <a:solidFill>
+            <a:srgbClr val="B68A3A"/>
+          </a:solidFill>
+          <a:ln>
+            <a:noFill/>
+          </a:ln>
+        </p:spPr>
+        <p:style>
+          <a:lnRef idx="1">
+            <a:schemeClr val="accent1"/>
+          </a:lnRef>
+          <a:fillRef idx="3">
+            <a:schemeClr val="accent1"/>
+          </a:fillRef>
+          <a:effectRef idx="2">
+            <a:schemeClr val="accent1"/>
+          </a:effectRef>
+          <a:fontRef idx="minor">
+            <a:schemeClr val="lt1"/>
+          </a:fontRef>
+        </p:style>
+        <p:txBody>
+          <a:bodyPr rtlCol="0" anchor="ctr"/>
+          <a:lstStyle/>
+          <a:p>
+            <a:pPr algn="ctr"/>
+          </a:p>
+        </p:txBody>
+      </p:sp>
+      <p:sp>
+        <p:nvSpPr>
+          <p:cNvPr id="7" name="Rectangle 6"/>
+          <p:cNvSpPr/>
+          <p:nvPr/>
+        </p:nvSpPr>
+        <p:spPr>
+          <a:xfrm>
+            <a:off x="310896" y="6536132"/>
+            <a:ext cx="8522208" cy="10972"/>
+          </a:xfrm>
+          <a:prstGeom prst="rect">
+            <a:avLst/>
+          </a:prstGeom>
+          <a:solidFill>
+            <a:srgbClr val="B68A3A"/>
+          </a:solidFill>
+          <a:ln>
+            <a:noFill/>
+          </a:ln>
+        </p:spPr>
+        <p:style>
+          <a:lnRef idx="1">
+            <a:schemeClr val="accent1"/>
+          </a:lnRef>
+          <a:fillRef idx="3">
+            <a:schemeClr val="accent1"/>
+          </a:fillRef>
+          <a:effectRef idx="2">
+            <a:schemeClr val="accent1"/>
+          </a:effectRef>
+          <a:fontRef idx="minor">
+            <a:schemeClr val="lt1"/>
+          </a:fontRef>
+        </p:style>
+        <p:txBody>
+          <a:bodyPr rtlCol="0" anchor="ctr"/>
+          <a:lstStyle/>
+          <a:p>
+            <a:pPr algn="ctr"/>
+          </a:p>
+        </p:txBody>
+      </p:sp>
+      <p:sp>
+        <p:nvSpPr>
+          <p:cNvPr id="8" name="Rectangle 7"/>
+          <p:cNvSpPr/>
+          <p:nvPr/>
+        </p:nvSpPr>
+        <p:spPr>
+          <a:xfrm>
+            <a:off x="310896" y="310896"/>
+            <a:ext cx="10972" cy="6236208"/>
+          </a:xfrm>
+          <a:prstGeom prst="rect">
+            <a:avLst/>
+          </a:prstGeom>
+          <a:solidFill>
+            <a:srgbClr val="B68A3A"/>
+          </a:solidFill>
+          <a:ln>
+            <a:noFill/>
+          </a:ln>
+        </p:spPr>
+        <p:style>
+          <a:lnRef idx="1">
+            <a:schemeClr val="accent1"/>
+          </a:lnRef>
+          <a:fillRef idx="3">
+            <a:schemeClr val="accent1"/>
+          </a:fillRef>
+          <a:effectRef idx="2">
+            <a:schemeClr val="accent1"/>
+          </a:effectRef>
+          <a:fontRef idx="minor">
+            <a:schemeClr val="lt1"/>
+          </a:fontRef>
+        </p:style>
+        <p:txBody>
+          <a:bodyPr rtlCol="0" anchor="ctr"/>
+          <a:lstStyle/>
+          <a:p>
+            <a:pPr algn="ctr"/>
+          </a:p>
+        </p:txBody>
+      </p:sp>
+      <p:sp>
+        <p:nvSpPr>
+          <p:cNvPr id="9" name="Rectangle 8"/>
+          <p:cNvSpPr/>
+          <p:nvPr/>
+        </p:nvSpPr>
+        <p:spPr>
+          <a:xfrm>
+            <a:off x="8822132" y="310896"/>
+            <a:ext cx="10972" cy="6236208"/>
+          </a:xfrm>
+          <a:prstGeom prst="rect">
+            <a:avLst/>
+          </a:prstGeom>
+          <a:solidFill>
+            <a:srgbClr val="B68A3A"/>
+          </a:solidFill>
+          <a:ln>
+            <a:noFill/>
+          </a:ln>
+        </p:spPr>
+        <p:style>
+          <a:lnRef idx="1">
+            <a:schemeClr val="accent1"/>
+          </a:lnRef>
+          <a:fillRef idx="3">
+            <a:schemeClr val="accent1"/>
+          </a:fillRef>
+          <a:effectRef idx="2">
+            <a:schemeClr val="accent1"/>
+          </a:effectRef>
+          <a:fontRef idx="minor">
+            <a:schemeClr val="lt1"/>
+          </a:fontRef>
+        </p:style>
+        <p:txBody>
+          <a:bodyPr rtlCol="0" anchor="ctr"/>
+          <a:lstStyle/>
+          <a:p>
+            <a:pPr algn="ctr"/>
+          </a:p>
+        </p:txBody>
+      </p:sp>
+      <p:sp>
+        <p:nvSpPr>
+          <p:cNvPr id="11" name="TextBox 10"/>
+          <p:cNvSpPr txBox="1"/>
+          <p:nvPr/>
+        </p:nvSpPr>
+        <p:spPr>
+          <a:xfrm>
+            <a:off x="457200" y="347472"/>
+            <a:ext cx="8229600" cy="320040"/>
+          </a:xfrm>
+          <a:prstGeom prst="rect">
+            <a:avLst/>
+          </a:prstGeom>
+          <a:noFill/>
+        </p:spPr>
+        <p:txBody>
+          <a:bodyPr wrap="square">
+            <a:spAutoFit/>
+          </a:bodyPr>
+          <a:lstStyle/>
+          <a:p>
+            <a:pPr algn="ctr"/>
+            <a:r>
+              <a:rPr sz="1100" b="1">
+                <a:solidFill>
+                  <a:srgbClr val="8B1E2D"/>
+                </a:solidFill>
+                <a:latin typeface="Liberation Serif"/>
+              </a:rPr>
+              <a:t>LORD SCHOOL | INTERNATIONAL PROGRAM DEVELOPMENT</a:t>
+            </a:r>
+          </a:p>
+        </p:txBody>
+      </p:sp>
+      <p:sp>
+        <p:nvSpPr>
+          <p:cNvPr id="12" name="TextBox 11"/>
+          <p:cNvSpPr txBox="1"/>
+          <p:nvPr/>
+        </p:nvSpPr>
+        <p:spPr>
+          <a:xfrm>
+            <a:off x="457200" y="6355080"/>
+            <a:ext cx="8229600" cy="274320"/>
+          </a:xfrm>
+          <a:prstGeom prst="rect">
+            <a:avLst/>
+          </a:prstGeom>
+          <a:noFill/>
+        </p:spPr>
+        <p:txBody>
+          <a:bodyPr wrap="square">
+            <a:spAutoFit/>
+          </a:bodyPr>
+          <a:lstStyle/>
+          <a:p>
+            <a:pPr algn="ctr"/>
+            <a:r>
+              <a:rPr sz="900" b="0">
+                <a:solidFill>
+                  <a:srgbClr val="666666"/>
+                </a:solidFill>
+                <a:latin typeface="Liberation Serif"/>
+              </a:rPr>
+              <a:t>Prepared by Mr. Waseem Allabadi - Success 4 Sure Academy</a:t>
+            </a:r>
+          </a:p>
+        </p:txBody>
+      </p:sp>
+      <p:sp>
+        <p:nvSpPr>
+          <p:cNvPr id="13" name="TextBox 12"/>
+          <p:cNvSpPr txBox="1"/>
+          <p:nvPr/>
+        </p:nvSpPr>
+        <p:spPr>
+          <a:xfrm>
+            <a:off x="502920" y="685800"/>
+            <a:ext cx="8138160" cy="365760"/>
+          </a:xfrm>
+          <a:prstGeom prst="rect">
+            <a:avLst/>
+          </a:prstGeom>
+          <a:noFill/>
+        </p:spPr>
+        <p:txBody>
+          <a:bodyPr wrap="square">
+            <a:spAutoFit/>
+          </a:bodyPr>
+          <a:lstStyle/>
+          <a:p>
+            <a:pPr algn="r" rtl="1"/>
+            <a:r>
+              <a:rPr sz="1800" b="1">
+                <a:solidFill>
+                  <a:srgbClr val="8B1E2D"/>
+                </a:solidFill>
+                <a:latin typeface="Amiri"/>
+              </a:rPr>
+              <a:t>6. النتيجة المتوقعة</a:t>
+            </a:r>
+          </a:p>
+        </p:txBody>
+      </p:sp>
+      <p:sp>
+        <p:nvSpPr>
+          <p:cNvPr id="14" name="TextBox 13"/>
+          <p:cNvSpPr txBox="1"/>
+          <p:nvPr/>
+        </p:nvSpPr>
+        <p:spPr>
+          <a:xfrm>
+            <a:off x="502920" y="1097280"/>
+            <a:ext cx="8138160" cy="1188720"/>
+          </a:xfrm>
+          <a:prstGeom prst="rect">
+            <a:avLst/>
+          </a:prstGeom>
+          <a:noFill/>
+        </p:spPr>
+        <p:txBody>
+          <a:bodyPr wrap="square">
+            <a:spAutoFit/>
+          </a:bodyPr>
+          <a:lstStyle/>
+          <a:p>
+            <a:pPr algn="r" rtl="1"/>
+            <a:r>
+              <a:rPr sz="1300" b="0">
+                <a:solidFill>
+                  <a:srgbClr val="232323"/>
+                </a:solidFill>
+                <a:latin typeface="Amiri"/>
+              </a:rPr>
+              <a:t>الهدف من الخطة ليس فقط معالجة الملاحظات الحالية، بل تحويل البرنامج الدولي إلى محرك نمو للمدرسة. يبدأ النجاح من السنة الأولى عبر تحسين البيئة التعليمية، تنظيم العمل الأكاديمي، رفع جودة المتابعة، واستقطاب الطلبة. وبعد إثبات النموذج واستقراره يمكن الانتقال بصورة مدروسة إلى طريق المطار، ثم شفا بدران، ثم مرحلة الانتشار الفعلي.</a:t>
+            </a:r>
+          </a:p>
+        </p:txBody>
+      </p:sp>
+      <p:sp>
+        <p:nvSpPr>
+          <p:cNvPr id="15" name="TextBox 14"/>
+          <p:cNvSpPr txBox="1"/>
+          <p:nvPr/>
+        </p:nvSpPr>
+        <p:spPr>
+          <a:xfrm>
+            <a:off x="502920" y="2377440"/>
+            <a:ext cx="8138160" cy="320040"/>
+          </a:xfrm>
+          <a:prstGeom prst="rect">
+            <a:avLst/>
+          </a:prstGeom>
+          <a:noFill/>
+        </p:spPr>
+        <p:txBody>
+          <a:bodyPr wrap="square">
+            <a:spAutoFit/>
+          </a:bodyPr>
+          <a:lstStyle/>
+          <a:p>
+            <a:pPr algn="r" rtl="1"/>
+            <a:r>
+              <a:rPr sz="1400" b="1">
+                <a:solidFill>
+                  <a:srgbClr val="8B1E2D"/>
+                </a:solidFill>
+                <a:latin typeface="Amiri"/>
+              </a:rPr>
+              <a:t>مبدأ التنفيذ</a:t>
+            </a:r>
+          </a:p>
+        </p:txBody>
+      </p:sp>
+      <p:sp>
+        <p:nvSpPr>
+          <p:cNvPr id="16" name="TextBox 15"/>
+          <p:cNvSpPr txBox="1"/>
+          <p:nvPr/>
+        </p:nvSpPr>
+        <p:spPr>
+          <a:xfrm>
+            <a:off x="502920" y="2743200"/>
+            <a:ext cx="8138160" cy="2011680"/>
+          </a:xfrm>
+          <a:prstGeom prst="rect">
+            <a:avLst/>
+          </a:prstGeom>
+          <a:noFill/>
+        </p:spPr>
+        <p:txBody>
+          <a:bodyPr wrap="square">
+            <a:spAutoFit/>
+          </a:bodyPr>
+          <a:lstStyle/>
+          <a:p>
+            <a:pPr algn="r" rtl="1">
+              <a:spcAft>
+                <a:spcPts val="400"/>
+              </a:spcAft>
+            </a:pPr>
+            <a:r>
+              <a:rPr sz="1300">
+                <a:solidFill>
+                  <a:srgbClr val="232323"/>
+                </a:solidFill>
+                <a:latin typeface="Amiri"/>
+              </a:rPr>
+              <a:t>• الأولوية للسنة الأولى والنتائج القابلة للقياس.</a:t>
+            </a:r>
+          </a:p>
+          <a:p>
+            <a:pPr algn="r" rtl="1">
+              <a:spcAft>
+                <a:spcPts val="400"/>
+              </a:spcAft>
+            </a:pPr>
+            <a:r>
+              <a:rPr sz="1300">
+                <a:solidFill>
+                  <a:srgbClr val="232323"/>
+                </a:solidFill>
+                <a:latin typeface="Amiri"/>
+              </a:rPr>
+              <a:t>• كل توسع لاحق مرتبط بتحقيق أهداف أكاديمية وتشغيلية ومالية واضحة.</a:t>
+            </a:r>
+          </a:p>
+          <a:p>
+            <a:pPr algn="r" rtl="1">
+              <a:spcAft>
+                <a:spcPts val="400"/>
+              </a:spcAft>
+            </a:pPr>
+            <a:r>
+              <a:rPr sz="1300">
+                <a:solidFill>
+                  <a:srgbClr val="232323"/>
+                </a:solidFill>
+                <a:latin typeface="Amiri"/>
+              </a:rPr>
+              <a:t>• التطوير يتم بالتعاون مع إدارة المدرسة وضمن الميزانيات والصلاحيات المعتمدة.</a:t>
+            </a:r>
+          </a:p>
+          <a:p>
+            <a:pPr algn="r" rtl="1">
+              <a:spcAft>
+                <a:spcPts val="400"/>
+              </a:spcAft>
+            </a:pPr>
+            <a:r>
+              <a:rPr sz="1300">
+                <a:solidFill>
+                  <a:srgbClr val="232323"/>
+                </a:solidFill>
+                <a:latin typeface="Amiri"/>
+              </a:rPr>
+              <a:t>• الأرقام الواردة تقديرية وتُحدَّث بعد الاطلاع على البيانات الرسمية.</a:t>
+            </a:r>
+          </a:p>
+        </p:txBody>
+      </p:sp>
+      <p:sp>
+        <p:nvSpPr>
+          <p:cNvPr id="17" name="TextBox 16"/>
+          <p:cNvSpPr txBox="1"/>
+          <p:nvPr/>
+        </p:nvSpPr>
+        <p:spPr>
+          <a:xfrm>
+            <a:off x="502920" y="4937760"/>
+            <a:ext cx="8138160" cy="320040"/>
+          </a:xfrm>
+          <a:prstGeom prst="rect">
+            <a:avLst/>
+          </a:prstGeom>
+          <a:noFill/>
+        </p:spPr>
+        <p:txBody>
+          <a:bodyPr wrap="square">
+            <a:spAutoFit/>
+          </a:bodyPr>
+          <a:lstStyle/>
+          <a:p>
+            <a:pPr algn="ctr" rtl="1"/>
+            <a:r>
+              <a:rPr sz="1400" b="1">
+                <a:solidFill>
+                  <a:srgbClr val="8B1E2D"/>
+                </a:solidFill>
+                <a:latin typeface="Amiri"/>
+              </a:rPr>
+              <a:t>الأستاذ وسيم اللبدي</a:t>
+            </a:r>
+          </a:p>
+        </p:txBody>
+      </p:sp>
+      <p:sp>
+        <p:nvSpPr>
+          <p:cNvPr id="18" name="TextBox 17"/>
+          <p:cNvSpPr txBox="1"/>
+          <p:nvPr/>
+        </p:nvSpPr>
+        <p:spPr>
+          <a:xfrm>
+            <a:off x="502920" y="5303520"/>
+            <a:ext cx="8138160" cy="320040"/>
+          </a:xfrm>
+          <a:prstGeom prst="rect">
+            <a:avLst/>
+          </a:prstGeom>
+          <a:noFill/>
+        </p:spPr>
+        <p:txBody>
+          <a:bodyPr wrap="square">
+            <a:spAutoFit/>
+          </a:bodyPr>
+          <a:lstStyle/>
+          <a:p>
+            <a:pPr algn="ctr" rtl="1"/>
+            <a:r>
+              <a:rPr sz="1200" b="0">
+                <a:solidFill>
+                  <a:srgbClr val="666666"/>
+                </a:solidFill>
+                <a:latin typeface="Amiri"/>
+              </a:rPr>
+              <a:t>مدير البرنامج الدولي - شركة النجاح الأكيد</a:t>
             </a:r>
           </a:p>
         </p:txBody>
@@ -4300,7 +5019,7 @@
                 </a:solidFill>
                 <a:latin typeface="Amiri"/>
               </a:rPr>
-              <a:t>تمتلك مدرسة اللورد قاعدة مناسبة للنمو والتطوير، إلا أن الاستفادة الحالية من طاقتها الاستيعابية ما تزال أقل من الإمكانات المتاحة.</a:t>
+              <a:t>تمتلك Lord School قاعدة مناسبة للنمو والتطوير، إلا أن الاستفادة الحالية من طاقتها الاستيعابية ما تزال أقل من الإمكانات المتاحة.</a:t>
             </a:r>
           </a:p>
         </p:txBody>
@@ -4384,7 +5103,7 @@
         <p:spPr>
           <a:xfrm>
             <a:off x="502920" y="2468879"/>
-            <a:ext cx="8138160" cy="3840480"/>
+            <a:ext cx="8138160" cy="2194560"/>
           </a:xfrm>
           <a:prstGeom prst="rect">
             <a:avLst/>
@@ -4403,7 +5122,7 @@
               </a:spcAft>
             </a:pPr>
             <a:r>
-              <a:rPr sz="1200">
+              <a:rPr sz="1100">
                 <a:solidFill>
                   <a:srgbClr val="232323"/>
                 </a:solidFill>
@@ -4419,7 +5138,7 @@
               </a:spcAft>
             </a:pPr>
             <a:r>
-              <a:rPr sz="1200">
+              <a:rPr sz="1100">
                 <a:solidFill>
                   <a:srgbClr val="232323"/>
                 </a:solidFill>
@@ -4435,7 +5154,7 @@
               </a:spcAft>
             </a:pPr>
             <a:r>
-              <a:rPr sz="1200">
+              <a:rPr sz="1100">
                 <a:solidFill>
                   <a:srgbClr val="232323"/>
                 </a:solidFill>
@@ -4451,7 +5170,7 @@
               </a:spcAft>
             </a:pPr>
             <a:r>
-              <a:rPr sz="1200">
+              <a:rPr sz="1100">
                 <a:solidFill>
                   <a:srgbClr val="232323"/>
                 </a:solidFill>
@@ -4467,7 +5186,7 @@
               </a:spcAft>
             </a:pPr>
             <a:r>
-              <a:rPr sz="1200">
+              <a:rPr sz="1100">
                 <a:solidFill>
                   <a:srgbClr val="232323"/>
                 </a:solidFill>
@@ -4478,6 +5197,30 @@
           </a:p>
         </p:txBody>
       </p:sp>
+      <p:pic>
+        <p:nvPicPr>
+          <p:cNvPr id="18" name="Picture 17" descr="chart_occupancy.png"/>
+          <p:cNvPicPr>
+            <a:picLocks noChangeAspect="1"/>
+          </p:cNvPicPr>
+          <p:nvPr/>
+        </p:nvPicPr>
+        <p:blipFill>
+          <a:blip r:embed="rId3"/>
+          <a:stretch>
+            <a:fillRect/>
+          </a:stretch>
+        </p:blipFill>
+        <p:spPr>
+          <a:xfrm>
+            <a:off x="1097280" y="4572000"/>
+            <a:ext cx="6949440" cy="3131066"/>
+          </a:xfrm>
+          <a:prstGeom prst="rect">
+            <a:avLst/>
+          </a:prstGeom>
+        </p:spPr>
+      </p:pic>
     </p:spTree>
   </p:cSld>
   <p:clrMapOvr>
@@ -7013,16 +7756,40 @@
           </a:p>
         </p:txBody>
       </p:sp>
-      <p:sp>
-        <p:nvSpPr>
-          <p:cNvPr id="14" name="TextBox 13"/>
+      <p:pic>
+        <p:nvPicPr>
+          <p:cNvPr id="14" name="Picture 13" descr="chart_roadmap.png"/>
+          <p:cNvPicPr>
+            <a:picLocks noChangeAspect="1"/>
+          </p:cNvPicPr>
+          <p:nvPr/>
+        </p:nvPicPr>
+        <p:blipFill>
+          <a:blip r:embed="rId3"/>
+          <a:stretch>
+            <a:fillRect/>
+          </a:stretch>
+        </p:blipFill>
+        <p:spPr>
+          <a:xfrm>
+            <a:off x="640080" y="1188720"/>
+            <a:ext cx="7863840" cy="3197385"/>
+          </a:xfrm>
+          <a:prstGeom prst="rect">
+            <a:avLst/>
+          </a:prstGeom>
+        </p:spPr>
+      </p:pic>
+      <p:sp>
+        <p:nvSpPr>
+          <p:cNvPr id="15" name="TextBox 14"/>
           <p:cNvSpPr txBox="1"/>
           <p:nvPr/>
         </p:nvSpPr>
         <p:spPr>
           <a:xfrm>
-            <a:off x="502920" y="1051560"/>
-            <a:ext cx="8138160" cy="320040"/>
+            <a:off x="502920" y="4846320"/>
+            <a:ext cx="8138160" cy="822960"/>
           </a:xfrm>
           <a:prstGeom prst="rect">
             <a:avLst/>
@@ -7037,328 +7804,13 @@
           <a:p>
             <a:pPr algn="r" rtl="1"/>
             <a:r>
-              <a:rPr sz="1400" b="1">
-                <a:solidFill>
-                  <a:srgbClr val="B68A3A"/>
-                </a:solidFill>
-                <a:latin typeface="Amiri"/>
-              </a:rPr>
-              <a:t>السنة الأولى: سنة إعادة البناء والانطلاق</a:t>
-            </a:r>
-          </a:p>
-        </p:txBody>
-      </p:sp>
-      <p:sp>
-        <p:nvSpPr>
-          <p:cNvPr id="15" name="TextBox 14"/>
-          <p:cNvSpPr txBox="1"/>
-          <p:nvPr/>
-        </p:nvSpPr>
-        <p:spPr>
-          <a:xfrm>
-            <a:off x="502920" y="1371600"/>
-            <a:ext cx="8138160" cy="594360"/>
-          </a:xfrm>
-          <a:prstGeom prst="rect">
-            <a:avLst/>
-          </a:prstGeom>
-          <a:noFill/>
-        </p:spPr>
-        <p:txBody>
-          <a:bodyPr wrap="square">
-            <a:spAutoFit/>
-          </a:bodyPr>
-          <a:lstStyle/>
-          <a:p>
-            <a:pPr algn="r" rtl="1"/>
-            <a:r>
-              <a:rPr sz="1200" b="0">
+              <a:rPr sz="1300" b="0">
                 <a:solidFill>
                   <a:srgbClr val="232323"/>
                 </a:solidFill>
                 <a:latin typeface="Amiri"/>
               </a:rPr>
               <a:t>السنة الأولى هي محور الخطة، والهدف منها معالجة الأولويات المباشرة، بناء برنامج دولي منظم، رفع الثقة، وخلق نمو حقيقي في التسجيل.</a:t>
-            </a:r>
-          </a:p>
-        </p:txBody>
-      </p:sp>
-      <p:sp>
-        <p:nvSpPr>
-          <p:cNvPr id="16" name="TextBox 15"/>
-          <p:cNvSpPr txBox="1"/>
-          <p:nvPr/>
-        </p:nvSpPr>
-        <p:spPr>
-          <a:xfrm>
-            <a:off x="502920" y="2057400"/>
-            <a:ext cx="8138160" cy="256032"/>
-          </a:xfrm>
-          <a:prstGeom prst="rect">
-            <a:avLst/>
-          </a:prstGeom>
-          <a:noFill/>
-        </p:spPr>
-        <p:txBody>
-          <a:bodyPr wrap="square">
-            <a:spAutoFit/>
-          </a:bodyPr>
-          <a:lstStyle/>
-          <a:p>
-            <a:pPr algn="r" rtl="1"/>
-            <a:r>
-              <a:rPr sz="1200" b="1">
-                <a:solidFill>
-                  <a:srgbClr val="8B1E2D"/>
-                </a:solidFill>
-                <a:latin typeface="Amiri"/>
-              </a:rPr>
-              <a:t>المرحلة الأولى: أول 30 يوماً</a:t>
-            </a:r>
-          </a:p>
-        </p:txBody>
-      </p:sp>
-      <p:sp>
-        <p:nvSpPr>
-          <p:cNvPr id="17" name="TextBox 16"/>
-          <p:cNvSpPr txBox="1"/>
-          <p:nvPr/>
-        </p:nvSpPr>
-        <p:spPr>
-          <a:xfrm>
-            <a:off x="502920" y="2313432"/>
-            <a:ext cx="8138160" cy="502920"/>
-          </a:xfrm>
-          <a:prstGeom prst="rect">
-            <a:avLst/>
-          </a:prstGeom>
-          <a:noFill/>
-        </p:spPr>
-        <p:txBody>
-          <a:bodyPr wrap="square">
-            <a:spAutoFit/>
-          </a:bodyPr>
-          <a:lstStyle/>
-          <a:p>
-            <a:pPr algn="r" rtl="1"/>
-            <a:r>
-              <a:rPr sz="1100" b="0">
-                <a:solidFill>
-                  <a:srgbClr val="232323"/>
-                </a:solidFill>
-                <a:latin typeface="Amiri"/>
-              </a:rPr>
-              <a:t>تقييم الطلبة والمعلمين، مراجعة البرامج الحالية، تحديد احتياجات المختبرات والصفوف، إعداد الهيكل التشغيلي، ووضع مؤشرات أداء واضحة.</a:t>
-            </a:r>
-          </a:p>
-        </p:txBody>
-      </p:sp>
-      <p:sp>
-        <p:nvSpPr>
-          <p:cNvPr id="18" name="TextBox 17"/>
-          <p:cNvSpPr txBox="1"/>
-          <p:nvPr/>
-        </p:nvSpPr>
-        <p:spPr>
-          <a:xfrm>
-            <a:off x="502920" y="2880360"/>
-            <a:ext cx="8138160" cy="256032"/>
-          </a:xfrm>
-          <a:prstGeom prst="rect">
-            <a:avLst/>
-          </a:prstGeom>
-          <a:noFill/>
-        </p:spPr>
-        <p:txBody>
-          <a:bodyPr wrap="square">
-            <a:spAutoFit/>
-          </a:bodyPr>
-          <a:lstStyle/>
-          <a:p>
-            <a:pPr algn="r" rtl="1"/>
-            <a:r>
-              <a:rPr sz="1200" b="1">
-                <a:solidFill>
-                  <a:srgbClr val="8B1E2D"/>
-                </a:solidFill>
-                <a:latin typeface="Amiri"/>
-              </a:rPr>
-              <a:t>المرحلة الثانية: من 30 إلى 90 يوماً</a:t>
-            </a:r>
-          </a:p>
-        </p:txBody>
-      </p:sp>
-      <p:sp>
-        <p:nvSpPr>
-          <p:cNvPr id="19" name="TextBox 18"/>
-          <p:cNvSpPr txBox="1"/>
-          <p:nvPr/>
-        </p:nvSpPr>
-        <p:spPr>
-          <a:xfrm>
-            <a:off x="502920" y="3136391"/>
-            <a:ext cx="8138160" cy="502920"/>
-          </a:xfrm>
-          <a:prstGeom prst="rect">
-            <a:avLst/>
-          </a:prstGeom>
-          <a:noFill/>
-        </p:spPr>
-        <p:txBody>
-          <a:bodyPr wrap="square">
-            <a:spAutoFit/>
-          </a:bodyPr>
-          <a:lstStyle/>
-          <a:p>
-            <a:pPr algn="r" rtl="1"/>
-            <a:r>
-              <a:rPr sz="1100" b="0">
-                <a:solidFill>
-                  <a:srgbClr val="232323"/>
-                </a:solidFill>
-                <a:latin typeface="Amiri"/>
-              </a:rPr>
-              <a:t>تنظيم الصفوف، بدء أعمال الصيانة ذات الأولوية، إعداد الهوية التسويقية للبرنامج الدولي، تدريب المعلمين، وتفعيل نظام متابعة الطلبة وأولياء الأمور.</a:t>
-            </a:r>
-          </a:p>
-        </p:txBody>
-      </p:sp>
-      <p:sp>
-        <p:nvSpPr>
-          <p:cNvPr id="20" name="TextBox 19"/>
-          <p:cNvSpPr txBox="1"/>
-          <p:nvPr/>
-        </p:nvSpPr>
-        <p:spPr>
-          <a:xfrm>
-            <a:off x="502920" y="3703320"/>
-            <a:ext cx="8138160" cy="256032"/>
-          </a:xfrm>
-          <a:prstGeom prst="rect">
-            <a:avLst/>
-          </a:prstGeom>
-          <a:noFill/>
-        </p:spPr>
-        <p:txBody>
-          <a:bodyPr wrap="square">
-            <a:spAutoFit/>
-          </a:bodyPr>
-          <a:lstStyle/>
-          <a:p>
-            <a:pPr algn="r" rtl="1"/>
-            <a:r>
-              <a:rPr sz="1200" b="1">
-                <a:solidFill>
-                  <a:srgbClr val="8B1E2D"/>
-                </a:solidFill>
-                <a:latin typeface="Amiri"/>
-              </a:rPr>
-              <a:t>المرحلة الثالثة: الفصل الأول</a:t>
-            </a:r>
-          </a:p>
-        </p:txBody>
-      </p:sp>
-      <p:sp>
-        <p:nvSpPr>
-          <p:cNvPr id="21" name="TextBox 20"/>
-          <p:cNvSpPr txBox="1"/>
-          <p:nvPr/>
-        </p:nvSpPr>
-        <p:spPr>
-          <a:xfrm>
-            <a:off x="502920" y="3959352"/>
-            <a:ext cx="8138160" cy="502920"/>
-          </a:xfrm>
-          <a:prstGeom prst="rect">
-            <a:avLst/>
-          </a:prstGeom>
-          <a:noFill/>
-        </p:spPr>
-        <p:txBody>
-          <a:bodyPr wrap="square">
-            <a:spAutoFit/>
-          </a:bodyPr>
-          <a:lstStyle/>
-          <a:p>
-            <a:pPr algn="r" rtl="1"/>
-            <a:r>
-              <a:rPr sz="1100" b="0">
-                <a:solidFill>
-                  <a:srgbClr val="232323"/>
-                </a:solidFill>
-                <a:latin typeface="Amiri"/>
-              </a:rPr>
-              <a:t>إطلاق حملة تسجيل موجهة، تنظيم أيام مفتوحة، إضافة البرامج المطلوبة، تفعيل المنصة التعليمية، وتحسين تجربة الطالب داخل الصف والمختبر.</a:t>
-            </a:r>
-          </a:p>
-        </p:txBody>
-      </p:sp>
-      <p:sp>
-        <p:nvSpPr>
-          <p:cNvPr id="22" name="TextBox 21"/>
-          <p:cNvSpPr txBox="1"/>
-          <p:nvPr/>
-        </p:nvSpPr>
-        <p:spPr>
-          <a:xfrm>
-            <a:off x="502920" y="4526280"/>
-            <a:ext cx="8138160" cy="256032"/>
-          </a:xfrm>
-          <a:prstGeom prst="rect">
-            <a:avLst/>
-          </a:prstGeom>
-          <a:noFill/>
-        </p:spPr>
-        <p:txBody>
-          <a:bodyPr wrap="square">
-            <a:spAutoFit/>
-          </a:bodyPr>
-          <a:lstStyle/>
-          <a:p>
-            <a:pPr algn="r" rtl="1"/>
-            <a:r>
-              <a:rPr sz="1200" b="1">
-                <a:solidFill>
-                  <a:srgbClr val="8B1E2D"/>
-                </a:solidFill>
-                <a:latin typeface="Amiri"/>
-              </a:rPr>
-              <a:t>المرحلة الرابعة: الفصل الثاني</a:t>
-            </a:r>
-          </a:p>
-        </p:txBody>
-      </p:sp>
-      <p:sp>
-        <p:nvSpPr>
-          <p:cNvPr id="23" name="TextBox 22"/>
-          <p:cNvSpPr txBox="1"/>
-          <p:nvPr/>
-        </p:nvSpPr>
-        <p:spPr>
-          <a:xfrm>
-            <a:off x="502920" y="4782312"/>
-            <a:ext cx="8138160" cy="502920"/>
-          </a:xfrm>
-          <a:prstGeom prst="rect">
-            <a:avLst/>
-          </a:prstGeom>
-          <a:noFill/>
-        </p:spPr>
-        <p:txBody>
-          <a:bodyPr wrap="square">
-            <a:spAutoFit/>
-          </a:bodyPr>
-          <a:lstStyle/>
-          <a:p>
-            <a:pPr algn="r" rtl="1"/>
-            <a:r>
-              <a:rPr sz="1100" b="0">
-                <a:solidFill>
-                  <a:srgbClr val="232323"/>
-                </a:solidFill>
-                <a:latin typeface="Amiri"/>
-              </a:rPr>
-              <a:t>قياس النتائج، معالجة نقاط الضعف، توسيع الشراكات، التحضير للاعتمادات ومراكز الامتحانات، وإعداد خطة السنة الثانية بناءً على النتائج الفعلية.</a:t>
             </a:r>
           </a:p>
         </p:txBody>
@@ -7827,8 +8279,8 @@
         </p:nvSpPr>
         <p:spPr>
           <a:xfrm>
-            <a:off x="502920" y="685800"/>
-            <a:ext cx="8138160" cy="365760"/>
+            <a:off x="502920" y="640080"/>
+            <a:ext cx="8138160" cy="320040"/>
           </a:xfrm>
           <a:prstGeom prst="rect">
             <a:avLst/>
@@ -7843,152 +8295,251 @@
           <a:p>
             <a:pPr algn="r" rtl="1"/>
             <a:r>
-              <a:rPr sz="1600" b="1">
+              <a:rPr sz="1500" b="1">
                 <a:solidFill>
                   <a:srgbClr val="B68A3A"/>
                 </a:solidFill>
                 <a:latin typeface="Amiri"/>
               </a:rPr>
-              <a:t>أهداف السنة الأولى القابلة للقياس</a:t>
-            </a:r>
-          </a:p>
-        </p:txBody>
-      </p:sp>
-      <p:sp>
-        <p:nvSpPr>
-          <p:cNvPr id="14" name="TextBox 13"/>
-          <p:cNvSpPr txBox="1"/>
-          <p:nvPr/>
-        </p:nvSpPr>
-        <p:spPr>
-          <a:xfrm>
-            <a:off x="502920" y="1143000"/>
-            <a:ext cx="8138160" cy="5029200"/>
-          </a:xfrm>
-          <a:prstGeom prst="rect">
-            <a:avLst/>
-          </a:prstGeom>
-          <a:noFill/>
-        </p:spPr>
-        <p:txBody>
-          <a:bodyPr wrap="square">
-            <a:spAutoFit/>
-          </a:bodyPr>
-          <a:lstStyle/>
-          <a:p>
-            <a:pPr algn="r" rtl="1">
-              <a:spcAft>
-                <a:spcPts val="400"/>
-              </a:spcAft>
-            </a:pPr>
-            <a:r>
-              <a:rPr sz="1300">
-                <a:solidFill>
-                  <a:srgbClr val="232323"/>
-                </a:solidFill>
-                <a:latin typeface="Amiri"/>
-              </a:rPr>
-              <a:t>• رفع عدد طلبة المدرسة تدريجياً من نحو 300 إلى هدف تقريبي يصل إلى 400-450 طالباً، مع مراجعة الهدف بعد الاطلاع على بيانات التسجيل الفعلية.</a:t>
-            </a:r>
-          </a:p>
-          <a:p>
-            <a:pPr algn="r" rtl="1">
-              <a:spcAft>
-                <a:spcPts val="400"/>
-              </a:spcAft>
-            </a:pPr>
-            <a:r>
-              <a:rPr sz="1300">
-                <a:solidFill>
-                  <a:srgbClr val="232323"/>
-                </a:solidFill>
-                <a:latin typeface="Amiri"/>
-              </a:rPr>
-              <a:t>• بناء برنامج دولي منظم له هوية واضحة وخدمة متابعة أكاديمية مميزة.</a:t>
-            </a:r>
-          </a:p>
-          <a:p>
-            <a:pPr algn="r" rtl="1">
-              <a:spcAft>
-                <a:spcPts val="400"/>
-              </a:spcAft>
-            </a:pPr>
-            <a:r>
-              <a:rPr sz="1300">
-                <a:solidFill>
-                  <a:srgbClr val="232323"/>
-                </a:solidFill>
-                <a:latin typeface="Amiri"/>
-              </a:rPr>
-              <a:t>• إنهاء أعمال السلامة والصيانة الأساسية ذات الأثر المباشر على الطلبة.</a:t>
-            </a:r>
-          </a:p>
-          <a:p>
-            <a:pPr algn="r" rtl="1">
-              <a:spcAft>
-                <a:spcPts val="400"/>
-              </a:spcAft>
-            </a:pPr>
-            <a:r>
-              <a:rPr sz="1300">
-                <a:solidFill>
-                  <a:srgbClr val="232323"/>
-                </a:solidFill>
-                <a:latin typeface="Amiri"/>
-              </a:rPr>
-              <a:t>• تجهيز مختبر واحد على الأقل بصورة كاملة كنموذج أولي، ثم استكمال بقية المختبرات حسب الأولوية والميزانية.</a:t>
-            </a:r>
-          </a:p>
-          <a:p>
-            <a:pPr algn="r" rtl="1">
-              <a:spcAft>
-                <a:spcPts val="400"/>
-              </a:spcAft>
-            </a:pPr>
-            <a:r>
-              <a:rPr sz="1300">
-                <a:solidFill>
-                  <a:srgbClr val="232323"/>
-                </a:solidFill>
-                <a:latin typeface="Amiri"/>
-              </a:rPr>
-              <a:t>• تطبيق نظام تقييم ومتابعة للمعلمين، وتقارير دورية للطلبة وأولياء الأمور.</a:t>
-            </a:r>
-          </a:p>
-          <a:p>
-            <a:pPr algn="r" rtl="1">
-              <a:spcAft>
-                <a:spcPts val="400"/>
-              </a:spcAft>
-            </a:pPr>
-            <a:r>
-              <a:rPr sz="1300">
-                <a:solidFill>
-                  <a:srgbClr val="232323"/>
-                </a:solidFill>
-                <a:latin typeface="Amiri"/>
-              </a:rPr>
-              <a:t>• إطلاق تسويق تعليمي متخصص يركز على النتائج والخدمات والبرامج الدولية.</a:t>
-            </a:r>
-          </a:p>
-          <a:p>
-            <a:pPr algn="r" rtl="1">
-              <a:spcAft>
-                <a:spcPts val="400"/>
-              </a:spcAft>
-            </a:pPr>
-            <a:r>
-              <a:rPr sz="1300">
-                <a:solidFill>
-                  <a:srgbClr val="232323"/>
-                </a:solidFill>
-                <a:latin typeface="Amiri"/>
-              </a:rPr>
-              <a:t>• إعداد ملف الاعتماد أو مركز الامتحانات المناسب وبدء الخطوات الرسمية عند توفر الشروط.</a:t>
-            </a:r>
-          </a:p>
-        </p:txBody>
-      </p:sp>
+              <a:t>السنة الأولى: سنة إعادة البناء والانطلاق</a:t>
+            </a:r>
+          </a:p>
+        </p:txBody>
+      </p:sp>
+      <p:graphicFrame>
+        <p:nvGraphicFramePr>
+          <p:cNvPr id="14" name="Table 13"/>
+          <p:cNvGraphicFramePr>
+            <a:graphicFrameLocks noGrp="1"/>
+          </p:cNvGraphicFramePr>
+          <p:nvPr/>
+        </p:nvGraphicFramePr>
+        <p:xfrm>
+          <a:off x="457200" y="1051560"/>
+          <a:ext cx="8229600" cy="4114800"/>
+        </p:xfrm>
+        <a:graphic>
+          <a:graphicData uri="http://schemas.openxmlformats.org/drawingml/2006/table">
+            <a:tbl>
+              <a:tblPr firstRow="1" bandRow="1">
+                <a:tableStyleId>{5C22544A-7EE6-4342-B048-85BDC9FD1C3A}</a:tableStyleId>
+              </a:tblPr>
+              <a:tblGrid>
+                <a:gridCol w="5760720"/>
+                <a:gridCol w="2468880"/>
+              </a:tblGrid>
+              <a:tr h="822960">
+                <a:tc>
+                  <a:txBody>
+                    <a:bodyPr/>
+                    <a:lstStyle/>
+                    <a:p>
+                      <a:pPr algn="ctr" rtl="1"/>
+                      <a:r>
+                        <a:rPr b="1" sz="1200">
+                          <a:solidFill>
+                            <a:srgbClr val="FFFFFF"/>
+                          </a:solidFill>
+                          <a:latin typeface="Amiri"/>
+                        </a:rPr>
+                        <a:t>الأعمال الرئيسية</a:t>
+                      </a:r>
+                    </a:p>
+                  </a:txBody>
+                  <a:tcPr>
+                    <a:solidFill>
+                      <a:srgbClr val="8B1E2D"/>
+                    </a:solidFill>
+                  </a:tcPr>
+                </a:tc>
+                <a:tc>
+                  <a:txBody>
+                    <a:bodyPr/>
+                    <a:lstStyle/>
+                    <a:p>
+                      <a:pPr algn="ctr" rtl="1"/>
+                      <a:r>
+                        <a:rPr b="1" sz="1200">
+                          <a:solidFill>
+                            <a:srgbClr val="FFFFFF"/>
+                          </a:solidFill>
+                          <a:latin typeface="Amiri"/>
+                        </a:rPr>
+                        <a:t>المرحلة</a:t>
+                      </a:r>
+                    </a:p>
+                  </a:txBody>
+                  <a:tcPr>
+                    <a:solidFill>
+                      <a:srgbClr val="8B1E2D"/>
+                    </a:solidFill>
+                  </a:tcPr>
+                </a:tc>
+              </a:tr>
+              <a:tr h="822960">
+                <a:tc>
+                  <a:txBody>
+                    <a:bodyPr/>
+                    <a:lstStyle/>
+                    <a:p>
+                      <a:pPr algn="r" rtl="1"/>
+                      <a:r>
+                        <a:rPr sz="1100" b="0">
+                          <a:solidFill>
+                            <a:srgbClr val="232323"/>
+                          </a:solidFill>
+                          <a:latin typeface="Amiri"/>
+                        </a:rPr>
+                        <a:t>تقييم الطلبة والمعلمين، مراجعة البرامج الحالية، تحديد احتياجات المختبرات والصفوف، إعداد الهيكل التشغيلي، ووضع مؤشرات أداء واضحة.</a:t>
+                      </a:r>
+                    </a:p>
+                  </a:txBody>
+                  <a:tcPr/>
+                </a:tc>
+                <a:tc>
+                  <a:txBody>
+                    <a:bodyPr/>
+                    <a:lstStyle/>
+                    <a:p>
+                      <a:pPr algn="r" rtl="1"/>
+                      <a:r>
+                        <a:rPr sz="1100" b="1">
+                          <a:solidFill>
+                            <a:srgbClr val="8B1E2D"/>
+                          </a:solidFill>
+                          <a:latin typeface="Amiri"/>
+                        </a:rPr>
+                        <a:t>المرحلة الأولى: أول 30 يوماً</a:t>
+                      </a:r>
+                    </a:p>
+                  </a:txBody>
+                  <a:tcPr/>
+                </a:tc>
+              </a:tr>
+              <a:tr h="822960">
+                <a:tc>
+                  <a:txBody>
+                    <a:bodyPr/>
+                    <a:lstStyle/>
+                    <a:p>
+                      <a:pPr algn="r" rtl="1"/>
+                      <a:r>
+                        <a:rPr sz="1100" b="0">
+                          <a:solidFill>
+                            <a:srgbClr val="232323"/>
+                          </a:solidFill>
+                          <a:latin typeface="Amiri"/>
+                        </a:rPr>
+                        <a:t>تنظيم الصفوف، بدء أعمال الصيانة ذات الأولوية، إعداد الهوية التسويقية للبرنامج الدولي، تدريب المعلمين، وتفعيل نظام متابعة الطلبة وأولياء الأمور.</a:t>
+                      </a:r>
+                    </a:p>
+                  </a:txBody>
+                  <a:tcPr/>
+                </a:tc>
+                <a:tc>
+                  <a:txBody>
+                    <a:bodyPr/>
+                    <a:lstStyle/>
+                    <a:p>
+                      <a:pPr algn="r" rtl="1"/>
+                      <a:r>
+                        <a:rPr sz="1100" b="1">
+                          <a:solidFill>
+                            <a:srgbClr val="8B1E2D"/>
+                          </a:solidFill>
+                          <a:latin typeface="Amiri"/>
+                        </a:rPr>
+                        <a:t>المرحلة الثانية: من 30 إلى 90 يوماً</a:t>
+                      </a:r>
+                    </a:p>
+                  </a:txBody>
+                  <a:tcPr/>
+                </a:tc>
+              </a:tr>
+              <a:tr h="822960">
+                <a:tc>
+                  <a:txBody>
+                    <a:bodyPr/>
+                    <a:lstStyle/>
+                    <a:p>
+                      <a:pPr algn="r" rtl="1"/>
+                      <a:r>
+                        <a:rPr sz="1100" b="0">
+                          <a:solidFill>
+                            <a:srgbClr val="232323"/>
+                          </a:solidFill>
+                          <a:latin typeface="Amiri"/>
+                        </a:rPr>
+                        <a:t>إطلاق حملة تسجيل موجهة، تنظيم أيام مفتوحة، إضافة البرامج المطلوبة، تفعيل المنصة التعليمية، وتحسين تجربة الطالب داخل الصف والمختبر.</a:t>
+                      </a:r>
+                    </a:p>
+                  </a:txBody>
+                  <a:tcPr/>
+                </a:tc>
+                <a:tc>
+                  <a:txBody>
+                    <a:bodyPr/>
+                    <a:lstStyle/>
+                    <a:p>
+                      <a:pPr algn="r" rtl="1"/>
+                      <a:r>
+                        <a:rPr sz="1100" b="1">
+                          <a:solidFill>
+                            <a:srgbClr val="8B1E2D"/>
+                          </a:solidFill>
+                          <a:latin typeface="Amiri"/>
+                        </a:rPr>
+                        <a:t>المرحلة الثالثة: الفصل الأول</a:t>
+                      </a:r>
+                    </a:p>
+                  </a:txBody>
+                  <a:tcPr/>
+                </a:tc>
+              </a:tr>
+              <a:tr h="822960">
+                <a:tc>
+                  <a:txBody>
+                    <a:bodyPr/>
+                    <a:lstStyle/>
+                    <a:p>
+                      <a:pPr algn="r" rtl="1"/>
+                      <a:r>
+                        <a:rPr sz="1100" b="0">
+                          <a:solidFill>
+                            <a:srgbClr val="232323"/>
+                          </a:solidFill>
+                          <a:latin typeface="Amiri"/>
+                        </a:rPr>
+                        <a:t>قياس النتائج، معالجة نقاط الضعف، توسيع الشراكات، التحضير للاعتمادات ومراكز الامتحانات، وإعداد خطة السنة الثانية بناءً على النتائج الفعلية.</a:t>
+                      </a:r>
+                    </a:p>
+                  </a:txBody>
+                  <a:tcPr/>
+                </a:tc>
+                <a:tc>
+                  <a:txBody>
+                    <a:bodyPr/>
+                    <a:lstStyle/>
+                    <a:p>
+                      <a:pPr algn="r" rtl="1"/>
+                      <a:r>
+                        <a:rPr sz="1100" b="1">
+                          <a:solidFill>
+                            <a:srgbClr val="8B1E2D"/>
+                          </a:solidFill>
+                          <a:latin typeface="Amiri"/>
+                        </a:rPr>
+                        <a:t>المرحلة الرابعة: الفصل الثاني</a:t>
+                      </a:r>
+                    </a:p>
+                  </a:txBody>
+                  <a:tcPr/>
+                </a:tc>
+              </a:tr>
+            </a:tbl>
+          </a:graphicData>
+        </a:graphic>
+      </p:graphicFrame>
     </p:spTree>
   </p:cSld>
   <p:clrMapOvr>
@@ -8453,8 +9004,8 @@
         </p:nvSpPr>
         <p:spPr>
           <a:xfrm>
-            <a:off x="502920" y="685800"/>
-            <a:ext cx="8138160" cy="292608"/>
+            <a:off x="502920" y="640080"/>
+            <a:ext cx="8138160" cy="320040"/>
           </a:xfrm>
           <a:prstGeom prst="rect">
             <a:avLst/>
@@ -8469,27 +9020,51 @@
           <a:p>
             <a:pPr algn="r" rtl="1"/>
             <a:r>
-              <a:rPr sz="1300" b="1">
+              <a:rPr sz="1500" b="1">
                 <a:solidFill>
                   <a:srgbClr val="B68A3A"/>
                 </a:solidFill>
                 <a:latin typeface="Amiri"/>
               </a:rPr>
-              <a:t>السنة الثانية: التثبيت ورفع الإشغال</a:t>
-            </a:r>
-          </a:p>
-        </p:txBody>
-      </p:sp>
-      <p:sp>
-        <p:nvSpPr>
-          <p:cNvPr id="14" name="TextBox 13"/>
+              <a:t>أهداف السنة الأولى القابلة للقياس</a:t>
+            </a:r>
+          </a:p>
+        </p:txBody>
+      </p:sp>
+      <p:pic>
+        <p:nvPicPr>
+          <p:cNvPr id="14" name="Picture 13" descr="chart_phases.png"/>
+          <p:cNvPicPr>
+            <a:picLocks noChangeAspect="1"/>
+          </p:cNvPicPr>
+          <p:nvPr/>
+        </p:nvPicPr>
+        <p:blipFill>
+          <a:blip r:embed="rId3"/>
+          <a:stretch>
+            <a:fillRect/>
+          </a:stretch>
+        </p:blipFill>
+        <p:spPr>
+          <a:xfrm>
+            <a:off x="640080" y="1005840"/>
+            <a:ext cx="7863840" cy="3024554"/>
+          </a:xfrm>
+          <a:prstGeom prst="rect">
+            <a:avLst/>
+          </a:prstGeom>
+        </p:spPr>
+      </p:pic>
+      <p:sp>
+        <p:nvSpPr>
+          <p:cNvPr id="15" name="TextBox 14"/>
           <p:cNvSpPr txBox="1"/>
           <p:nvPr/>
         </p:nvSpPr>
         <p:spPr>
           <a:xfrm>
-            <a:off x="502920" y="978408"/>
-            <a:ext cx="8138160" cy="292608"/>
+            <a:off x="502920" y="3383280"/>
+            <a:ext cx="8138160" cy="2743200"/>
           </a:xfrm>
           <a:prstGeom prst="rect">
             <a:avLst/>
@@ -8502,330 +9077,115 @@
           </a:bodyPr>
           <a:lstStyle/>
           <a:p>
-            <a:pPr algn="r" rtl="1"/>
-            <a:r>
-              <a:rPr sz="1100" b="0">
+            <a:pPr algn="r" rtl="1">
+              <a:spcAft>
+                <a:spcPts val="400"/>
+              </a:spcAft>
+            </a:pPr>
+            <a:r>
+              <a:rPr sz="1200">
                 <a:solidFill>
                   <a:srgbClr val="232323"/>
                 </a:solidFill>
                 <a:latin typeface="Amiri"/>
               </a:rPr>
-              <a:t>• توسيع البرنامج الدولي وإضافة التخصصات والبرامج التي أثبتت وجود طلب عليها.</a:t>
-            </a:r>
-          </a:p>
-        </p:txBody>
-      </p:sp>
-      <p:sp>
-        <p:nvSpPr>
-          <p:cNvPr id="15" name="TextBox 14"/>
-          <p:cNvSpPr txBox="1"/>
-          <p:nvPr/>
-        </p:nvSpPr>
-        <p:spPr>
-          <a:xfrm>
-            <a:off x="502920" y="1271016"/>
-            <a:ext cx="8138160" cy="292608"/>
-          </a:xfrm>
-          <a:prstGeom prst="rect">
-            <a:avLst/>
-          </a:prstGeom>
-          <a:noFill/>
-        </p:spPr>
-        <p:txBody>
-          <a:bodyPr wrap="square">
-            <a:spAutoFit/>
-          </a:bodyPr>
-          <a:lstStyle/>
-          <a:p>
-            <a:pPr algn="r" rtl="1"/>
-            <a:r>
-              <a:rPr sz="1100" b="0">
+              <a:t>• رفع عدد طلبة المدرسة تدريجياً من نحو 300 إلى هدف تقريبي يصل إلى 400-450 طالباً، مع مراجعة الهدف بعد الاطلاع على بيانات التسجيل الفعلية.</a:t>
+            </a:r>
+          </a:p>
+          <a:p>
+            <a:pPr algn="r" rtl="1">
+              <a:spcAft>
+                <a:spcPts val="400"/>
+              </a:spcAft>
+            </a:pPr>
+            <a:r>
+              <a:rPr sz="1200">
                 <a:solidFill>
                   <a:srgbClr val="232323"/>
                 </a:solidFill>
                 <a:latin typeface="Amiri"/>
               </a:rPr>
-              <a:t>• رفع الإشغال في المبنى الحالي، وتحسين الاستدامة المالية وجودة الخدمات.</a:t>
-            </a:r>
-          </a:p>
-        </p:txBody>
-      </p:sp>
-      <p:sp>
-        <p:nvSpPr>
-          <p:cNvPr id="16" name="TextBox 15"/>
-          <p:cNvSpPr txBox="1"/>
-          <p:nvPr/>
-        </p:nvSpPr>
-        <p:spPr>
-          <a:xfrm>
-            <a:off x="502920" y="1563624"/>
-            <a:ext cx="8138160" cy="292608"/>
-          </a:xfrm>
-          <a:prstGeom prst="rect">
-            <a:avLst/>
-          </a:prstGeom>
-          <a:noFill/>
-        </p:spPr>
-        <p:txBody>
-          <a:bodyPr wrap="square">
-            <a:spAutoFit/>
-          </a:bodyPr>
-          <a:lstStyle/>
-          <a:p>
-            <a:pPr algn="r" rtl="1"/>
-            <a:r>
-              <a:rPr sz="1100" b="0">
+              <a:t>• بناء برنامج دولي منظم له هوية واضحة وخدمة متابعة أكاديمية مميزة.</a:t>
+            </a:r>
+          </a:p>
+          <a:p>
+            <a:pPr algn="r" rtl="1">
+              <a:spcAft>
+                <a:spcPts val="400"/>
+              </a:spcAft>
+            </a:pPr>
+            <a:r>
+              <a:rPr sz="1200">
                 <a:solidFill>
                   <a:srgbClr val="232323"/>
                 </a:solidFill>
                 <a:latin typeface="Amiri"/>
               </a:rPr>
-              <a:t>• بناء فريق قيادة أكاديمية قادر على إدارة النمو دون الاعتماد على شخص واحد.</a:t>
-            </a:r>
-          </a:p>
-        </p:txBody>
-      </p:sp>
-      <p:sp>
-        <p:nvSpPr>
-          <p:cNvPr id="17" name="TextBox 16"/>
-          <p:cNvSpPr txBox="1"/>
-          <p:nvPr/>
-        </p:nvSpPr>
-        <p:spPr>
-          <a:xfrm>
-            <a:off x="502920" y="1856232"/>
-            <a:ext cx="8138160" cy="292608"/>
-          </a:xfrm>
-          <a:prstGeom prst="rect">
-            <a:avLst/>
-          </a:prstGeom>
-          <a:noFill/>
-        </p:spPr>
-        <p:txBody>
-          <a:bodyPr wrap="square">
-            <a:spAutoFit/>
-          </a:bodyPr>
-          <a:lstStyle/>
-          <a:p>
-            <a:pPr algn="r" rtl="1"/>
-            <a:r>
-              <a:rPr sz="1100" b="0">
+              <a:t>• إنهاء أعمال السلامة والصيانة الأساسية ذات الأثر المباشر على الطلبة.</a:t>
+            </a:r>
+          </a:p>
+          <a:p>
+            <a:pPr algn="r" rtl="1">
+              <a:spcAft>
+                <a:spcPts val="400"/>
+              </a:spcAft>
+            </a:pPr>
+            <a:r>
+              <a:rPr sz="1200">
                 <a:solidFill>
                   <a:srgbClr val="232323"/>
                 </a:solidFill>
                 <a:latin typeface="Amiri"/>
               </a:rPr>
-              <a:t>• إعداد دراسة جدوى تفصيلية للفرع الثاني وتحديد الموقع والميزانية والنموذج التشغيلي.</a:t>
-            </a:r>
-          </a:p>
-        </p:txBody>
-      </p:sp>
-      <p:sp>
-        <p:nvSpPr>
-          <p:cNvPr id="18" name="TextBox 17"/>
-          <p:cNvSpPr txBox="1"/>
-          <p:nvPr/>
-        </p:nvSpPr>
-        <p:spPr>
-          <a:xfrm>
-            <a:off x="502920" y="2258568"/>
-            <a:ext cx="8138160" cy="292608"/>
-          </a:xfrm>
-          <a:prstGeom prst="rect">
-            <a:avLst/>
-          </a:prstGeom>
-          <a:noFill/>
-        </p:spPr>
-        <p:txBody>
-          <a:bodyPr wrap="square">
-            <a:spAutoFit/>
-          </a:bodyPr>
-          <a:lstStyle/>
-          <a:p>
-            <a:pPr algn="r" rtl="1"/>
-            <a:r>
-              <a:rPr sz="1300" b="1">
-                <a:solidFill>
-                  <a:srgbClr val="B68A3A"/>
+              <a:t>• تجهيز مختبر واحد على الأقل بصورة كاملة كنموذج أولي، ثم استكمال بقية المختبرات حسب الأولوية والميزانية.</a:t>
+            </a:r>
+          </a:p>
+          <a:p>
+            <a:pPr algn="r" rtl="1">
+              <a:spcAft>
+                <a:spcPts val="400"/>
+              </a:spcAft>
+            </a:pPr>
+            <a:r>
+              <a:rPr sz="1200">
+                <a:solidFill>
+                  <a:srgbClr val="232323"/>
                 </a:solidFill>
                 <a:latin typeface="Amiri"/>
               </a:rPr>
-              <a:t>السنة الثالثة: فرع طريق المطار</a:t>
-            </a:r>
-          </a:p>
-        </p:txBody>
-      </p:sp>
-      <p:sp>
-        <p:nvSpPr>
-          <p:cNvPr id="19" name="TextBox 18"/>
-          <p:cNvSpPr txBox="1"/>
-          <p:nvPr/>
-        </p:nvSpPr>
-        <p:spPr>
-          <a:xfrm>
-            <a:off x="502920" y="2551176"/>
-            <a:ext cx="8138160" cy="411480"/>
-          </a:xfrm>
-          <a:prstGeom prst="rect">
-            <a:avLst/>
-          </a:prstGeom>
-          <a:noFill/>
-        </p:spPr>
-        <p:txBody>
-          <a:bodyPr wrap="square">
-            <a:spAutoFit/>
-          </a:bodyPr>
-          <a:lstStyle/>
-          <a:p>
-            <a:pPr algn="r" rtl="1"/>
-            <a:r>
-              <a:rPr sz="1100" b="0">
+              <a:t>• تطبيق نظام تقييم ومتابعة للمعلمين، وتقارير دورية للطلبة وأولياء الأمور.</a:t>
+            </a:r>
+          </a:p>
+          <a:p>
+            <a:pPr algn="r" rtl="1">
+              <a:spcAft>
+                <a:spcPts val="400"/>
+              </a:spcAft>
+            </a:pPr>
+            <a:r>
+              <a:rPr sz="1200">
                 <a:solidFill>
                   <a:srgbClr val="232323"/>
                 </a:solidFill>
                 <a:latin typeface="Amiri"/>
               </a:rPr>
-              <a:t>بعد تحقيق مؤشرات السنتين الأولى والثانية، تستهدف الخطة افتتاح فرع جديد على طريق المطار، مع نقل النموذج الأكاديمي الناجح وتوحيد الجودة والإدارة بين الفرعين.</a:t>
-            </a:r>
-          </a:p>
-        </p:txBody>
-      </p:sp>
-      <p:sp>
-        <p:nvSpPr>
-          <p:cNvPr id="20" name="TextBox 19"/>
-          <p:cNvSpPr txBox="1"/>
-          <p:nvPr/>
-        </p:nvSpPr>
-        <p:spPr>
-          <a:xfrm>
-            <a:off x="502920" y="3044952"/>
-            <a:ext cx="8138160" cy="292608"/>
-          </a:xfrm>
-          <a:prstGeom prst="rect">
-            <a:avLst/>
-          </a:prstGeom>
-          <a:noFill/>
-        </p:spPr>
-        <p:txBody>
-          <a:bodyPr wrap="square">
-            <a:spAutoFit/>
-          </a:bodyPr>
-          <a:lstStyle/>
-          <a:p>
-            <a:pPr algn="r" rtl="1"/>
-            <a:r>
-              <a:rPr sz="1300" b="1">
-                <a:solidFill>
-                  <a:srgbClr val="B68A3A"/>
+              <a:t>• إطلاق تسويق تعليمي متخصص يركز على النتائج والخدمات والبرامج الدولية.</a:t>
+            </a:r>
+          </a:p>
+          <a:p>
+            <a:pPr algn="r" rtl="1">
+              <a:spcAft>
+                <a:spcPts val="400"/>
+              </a:spcAft>
+            </a:pPr>
+            <a:r>
+              <a:rPr sz="1200">
+                <a:solidFill>
+                  <a:srgbClr val="232323"/>
                 </a:solidFill>
                 <a:latin typeface="Amiri"/>
               </a:rPr>
-              <a:t>السنة الرابعة: فرع شفا بدران</a:t>
-            </a:r>
-          </a:p>
-        </p:txBody>
-      </p:sp>
-      <p:sp>
-        <p:nvSpPr>
-          <p:cNvPr id="21" name="TextBox 20"/>
-          <p:cNvSpPr txBox="1"/>
-          <p:nvPr/>
-        </p:nvSpPr>
-        <p:spPr>
-          <a:xfrm>
-            <a:off x="502920" y="3337560"/>
-            <a:ext cx="8138160" cy="411480"/>
-          </a:xfrm>
-          <a:prstGeom prst="rect">
-            <a:avLst/>
-          </a:prstGeom>
-          <a:noFill/>
-        </p:spPr>
-        <p:txBody>
-          <a:bodyPr wrap="square">
-            <a:spAutoFit/>
-          </a:bodyPr>
-          <a:lstStyle/>
-          <a:p>
-            <a:pPr algn="r" rtl="1"/>
-            <a:r>
-              <a:rPr sz="1100" b="0">
-                <a:solidFill>
-                  <a:srgbClr val="232323"/>
-                </a:solidFill>
-                <a:latin typeface="Amiri"/>
-              </a:rPr>
-              <a:t>في حال نجاح فرع طريق المطار واستقرار المدرسة الأم، تستهدف الخطة افتتاح فرع في شفا بدران، مع توسيع البرامج الدولية وبناء إدارة مركزية مشتركة للموارد البشرية والجودة والتسويق والمالية.</a:t>
-            </a:r>
-          </a:p>
-        </p:txBody>
-      </p:sp>
-      <p:sp>
-        <p:nvSpPr>
-          <p:cNvPr id="22" name="TextBox 21"/>
-          <p:cNvSpPr txBox="1"/>
-          <p:nvPr/>
-        </p:nvSpPr>
-        <p:spPr>
-          <a:xfrm>
-            <a:off x="502920" y="3831336"/>
-            <a:ext cx="8138160" cy="292608"/>
-          </a:xfrm>
-          <a:prstGeom prst="rect">
-            <a:avLst/>
-          </a:prstGeom>
-          <a:noFill/>
-        </p:spPr>
-        <p:txBody>
-          <a:bodyPr wrap="square">
-            <a:spAutoFit/>
-          </a:bodyPr>
-          <a:lstStyle/>
-          <a:p>
-            <a:pPr algn="r" rtl="1"/>
-            <a:r>
-              <a:rPr sz="1300" b="1">
-                <a:solidFill>
-                  <a:srgbClr val="B68A3A"/>
-                </a:solidFill>
-                <a:latin typeface="Amiri"/>
-              </a:rPr>
-              <a:t>السنة الخامسة: بدء مرحلة الانتشار الفعلية</a:t>
-            </a:r>
-          </a:p>
-        </p:txBody>
-      </p:sp>
-      <p:sp>
-        <p:nvSpPr>
-          <p:cNvPr id="23" name="TextBox 22"/>
-          <p:cNvSpPr txBox="1"/>
-          <p:nvPr/>
-        </p:nvSpPr>
-        <p:spPr>
-          <a:xfrm>
-            <a:off x="502920" y="4123944"/>
-            <a:ext cx="8138160" cy="411480"/>
-          </a:xfrm>
-          <a:prstGeom prst="rect">
-            <a:avLst/>
-          </a:prstGeom>
-          <a:noFill/>
-        </p:spPr>
-        <p:txBody>
-          <a:bodyPr wrap="square">
-            <a:spAutoFit/>
-          </a:bodyPr>
-          <a:lstStyle/>
-          <a:p>
-            <a:pPr algn="r" rtl="1"/>
-            <a:r>
-              <a:rPr sz="1100" b="0">
-                <a:solidFill>
-                  <a:srgbClr val="232323"/>
-                </a:solidFill>
-                <a:latin typeface="Amiri"/>
-              </a:rPr>
-              <a:t>تبدأ المدرسة في السنة الخامسة مرحلة الانتشار المؤسسي الفعلي، من خلال اختيار مواقع إضافية داخل الأردن، أو بناء شراكات وفروع تعمل تحت اسم ونظام أكاديمي موحد، مع الحفاظ على الجودة وعدم التوسع أسرع من قدرة الإدارة على المتابعة.</a:t>
+              <a:t>• إعداد ملف الاعتماد أو مركز الامتحانات المناسب وبدء الخطوات الرسمية عند توفر الشروط.</a:t>
             </a:r>
           </a:p>
         </p:txBody>
@@ -9295,7 +9655,7 @@
         <p:spPr>
           <a:xfrm>
             <a:off x="502920" y="685800"/>
-            <a:ext cx="8138160" cy="365760"/>
+            <a:ext cx="8138160" cy="292608"/>
           </a:xfrm>
           <a:prstGeom prst="rect">
             <a:avLst/>
@@ -9310,13 +9670,13 @@
           <a:p>
             <a:pPr algn="r" rtl="1"/>
             <a:r>
-              <a:rPr sz="1800" b="1">
-                <a:solidFill>
-                  <a:srgbClr val="8B1E2D"/>
+              <a:rPr sz="1300" b="1">
+                <a:solidFill>
+                  <a:srgbClr val="B68A3A"/>
                 </a:solidFill>
                 <a:latin typeface="Amiri"/>
               </a:rPr>
-              <a:t>6. النتيجة المتوقعة</a:t>
+              <a:t>السنة الثانية: التثبيت ورفع الإشغال</a:t>
             </a:r>
           </a:p>
         </p:txBody>
@@ -9329,8 +9689,8 @@
         </p:nvSpPr>
         <p:spPr>
           <a:xfrm>
-            <a:off x="502920" y="1097280"/>
-            <a:ext cx="8138160" cy="1188720"/>
+            <a:off x="502920" y="978408"/>
+            <a:ext cx="8138160" cy="292608"/>
           </a:xfrm>
           <a:prstGeom prst="rect">
             <a:avLst/>
@@ -9345,13 +9705,13 @@
           <a:p>
             <a:pPr algn="r" rtl="1"/>
             <a:r>
-              <a:rPr sz="1300" b="0">
+              <a:rPr sz="1100" b="0">
                 <a:solidFill>
                   <a:srgbClr val="232323"/>
                 </a:solidFill>
                 <a:latin typeface="Amiri"/>
               </a:rPr>
-              <a:t>الهدف من الخطة ليس فقط معالجة الملاحظات الحالية، بل تحويل البرنامج الدولي إلى محرك نمو للمدرسة. يبدأ النجاح من السنة الأولى عبر تحسين البيئة التعليمية، تنظيم العمل الأكاديمي، رفع جودة المتابعة، واستقطاب الطلبة. وبعد إثبات النموذج واستقراره يمكن الانتقال بصورة مدروسة إلى طريق المطار، ثم شفا بدران، ثم مرحلة الانتشار الفعلي.</a:t>
+              <a:t>• توسيع البرنامج الدولي وإضافة التخصصات والبرامج التي أثبتت وجود طلب عليها.</a:t>
             </a:r>
           </a:p>
         </p:txBody>
@@ -9364,8 +9724,8 @@
         </p:nvSpPr>
         <p:spPr>
           <a:xfrm>
-            <a:off x="502920" y="2377440"/>
-            <a:ext cx="8138160" cy="320040"/>
+            <a:off x="502920" y="1271016"/>
+            <a:ext cx="8138160" cy="292608"/>
           </a:xfrm>
           <a:prstGeom prst="rect">
             <a:avLst/>
@@ -9380,13 +9740,13 @@
           <a:p>
             <a:pPr algn="r" rtl="1"/>
             <a:r>
-              <a:rPr sz="1400" b="1">
-                <a:solidFill>
-                  <a:srgbClr val="8B1E2D"/>
+              <a:rPr sz="1100" b="0">
+                <a:solidFill>
+                  <a:srgbClr val="232323"/>
                 </a:solidFill>
                 <a:latin typeface="Amiri"/>
               </a:rPr>
-              <a:t>مبدأ التنفيذ</a:t>
+              <a:t>• رفع الإشغال في المبنى الحالي، وتحسين الاستدامة المالية وجودة الخدمات.</a:t>
             </a:r>
           </a:p>
         </p:txBody>
@@ -9399,8 +9759,8 @@
         </p:nvSpPr>
         <p:spPr>
           <a:xfrm>
-            <a:off x="502920" y="2743200"/>
-            <a:ext cx="8138160" cy="2011680"/>
+            <a:off x="502920" y="1563624"/>
+            <a:ext cx="8138160" cy="292608"/>
           </a:xfrm>
           <a:prstGeom prst="rect">
             <a:avLst/>
@@ -9413,67 +9773,15 @@
           </a:bodyPr>
           <a:lstStyle/>
           <a:p>
-            <a:pPr algn="r" rtl="1">
-              <a:spcAft>
-                <a:spcPts val="400"/>
-              </a:spcAft>
-            </a:pPr>
-            <a:r>
-              <a:rPr sz="1300">
+            <a:pPr algn="r" rtl="1"/>
+            <a:r>
+              <a:rPr sz="1100" b="0">
                 <a:solidFill>
                   <a:srgbClr val="232323"/>
                 </a:solidFill>
                 <a:latin typeface="Amiri"/>
               </a:rPr>
-              <a:t>• الأولوية للسنة الأولى والنتائج القابلة للقياس.</a:t>
-            </a:r>
-          </a:p>
-          <a:p>
-            <a:pPr algn="r" rtl="1">
-              <a:spcAft>
-                <a:spcPts val="400"/>
-              </a:spcAft>
-            </a:pPr>
-            <a:r>
-              <a:rPr sz="1300">
-                <a:solidFill>
-                  <a:srgbClr val="232323"/>
-                </a:solidFill>
-                <a:latin typeface="Amiri"/>
-              </a:rPr>
-              <a:t>• كل توسع لاحق مرتبط بتحقيق أهداف أكاديمية وتشغيلية ومالية واضحة.</a:t>
-            </a:r>
-          </a:p>
-          <a:p>
-            <a:pPr algn="r" rtl="1">
-              <a:spcAft>
-                <a:spcPts val="400"/>
-              </a:spcAft>
-            </a:pPr>
-            <a:r>
-              <a:rPr sz="1300">
-                <a:solidFill>
-                  <a:srgbClr val="232323"/>
-                </a:solidFill>
-                <a:latin typeface="Amiri"/>
-              </a:rPr>
-              <a:t>• التطوير يتم بالتعاون مع إدارة المدرسة وضمن الميزانيات والصلاحيات المعتمدة.</a:t>
-            </a:r>
-          </a:p>
-          <a:p>
-            <a:pPr algn="r" rtl="1">
-              <a:spcAft>
-                <a:spcPts val="400"/>
-              </a:spcAft>
-            </a:pPr>
-            <a:r>
-              <a:rPr sz="1300">
-                <a:solidFill>
-                  <a:srgbClr val="232323"/>
-                </a:solidFill>
-                <a:latin typeface="Amiri"/>
-              </a:rPr>
-              <a:t>• الأرقام الواردة تقديرية وتُحدَّث بعد الاطلاع على البيانات الرسمية.</a:t>
+              <a:t>• بناء فريق قيادة أكاديمية قادر على إدارة النمو دون الاعتماد على شخص واحد.</a:t>
             </a:r>
           </a:p>
         </p:txBody>
@@ -9486,8 +9794,8 @@
         </p:nvSpPr>
         <p:spPr>
           <a:xfrm>
-            <a:off x="502920" y="4937760"/>
-            <a:ext cx="8138160" cy="320040"/>
+            <a:off x="502920" y="1856232"/>
+            <a:ext cx="8138160" cy="292608"/>
           </a:xfrm>
           <a:prstGeom prst="rect">
             <a:avLst/>
@@ -9500,15 +9808,15 @@
           </a:bodyPr>
           <a:lstStyle/>
           <a:p>
-            <a:pPr algn="ctr" rtl="1"/>
-            <a:r>
-              <a:rPr sz="1400" b="1">
-                <a:solidFill>
-                  <a:srgbClr val="8B1E2D"/>
+            <a:pPr algn="r" rtl="1"/>
+            <a:r>
+              <a:rPr sz="1100" b="0">
+                <a:solidFill>
+                  <a:srgbClr val="232323"/>
                 </a:solidFill>
                 <a:latin typeface="Amiri"/>
               </a:rPr>
-              <a:t>الأستاذ وسيم اللبدي</a:t>
+              <a:t>• إعداد دراسة جدوى تفصيلية للفرع الثاني وتحديد الموقع والميزانية والنموذج التشغيلي.</a:t>
             </a:r>
           </a:p>
         </p:txBody>
@@ -9521,8 +9829,8 @@
         </p:nvSpPr>
         <p:spPr>
           <a:xfrm>
-            <a:off x="502920" y="5303520"/>
-            <a:ext cx="8138160" cy="320040"/>
+            <a:off x="502920" y="2258568"/>
+            <a:ext cx="8138160" cy="292608"/>
           </a:xfrm>
           <a:prstGeom prst="rect">
             <a:avLst/>
@@ -9535,15 +9843,190 @@
           </a:bodyPr>
           <a:lstStyle/>
           <a:p>
-            <a:pPr algn="ctr" rtl="1"/>
-            <a:r>
-              <a:rPr sz="1200" b="0">
-                <a:solidFill>
-                  <a:srgbClr val="666666"/>
+            <a:pPr algn="r" rtl="1"/>
+            <a:r>
+              <a:rPr sz="1300" b="1">
+                <a:solidFill>
+                  <a:srgbClr val="B68A3A"/>
                 </a:solidFill>
                 <a:latin typeface="Amiri"/>
               </a:rPr>
-              <a:t>مدير البرنامج الدولي - شركة النجاح الأكيد</a:t>
+              <a:t>السنة الثالثة: فرع طريق المطار</a:t>
+            </a:r>
+          </a:p>
+        </p:txBody>
+      </p:sp>
+      <p:sp>
+        <p:nvSpPr>
+          <p:cNvPr id="19" name="TextBox 18"/>
+          <p:cNvSpPr txBox="1"/>
+          <p:nvPr/>
+        </p:nvSpPr>
+        <p:spPr>
+          <a:xfrm>
+            <a:off x="502920" y="2551176"/>
+            <a:ext cx="8138160" cy="411480"/>
+          </a:xfrm>
+          <a:prstGeom prst="rect">
+            <a:avLst/>
+          </a:prstGeom>
+          <a:noFill/>
+        </p:spPr>
+        <p:txBody>
+          <a:bodyPr wrap="square">
+            <a:spAutoFit/>
+          </a:bodyPr>
+          <a:lstStyle/>
+          <a:p>
+            <a:pPr algn="r" rtl="1"/>
+            <a:r>
+              <a:rPr sz="1100" b="0">
+                <a:solidFill>
+                  <a:srgbClr val="232323"/>
+                </a:solidFill>
+                <a:latin typeface="Amiri"/>
+              </a:rPr>
+              <a:t>بعد تحقيق مؤشرات السنتين الأولى والثانية، تستهدف الخطة افتتاح فرع جديد على طريق المطار، مع نقل النموذج الأكاديمي الناجح وتوحيد الجودة والإدارة بين الفرعين.</a:t>
+            </a:r>
+          </a:p>
+        </p:txBody>
+      </p:sp>
+      <p:sp>
+        <p:nvSpPr>
+          <p:cNvPr id="20" name="TextBox 19"/>
+          <p:cNvSpPr txBox="1"/>
+          <p:nvPr/>
+        </p:nvSpPr>
+        <p:spPr>
+          <a:xfrm>
+            <a:off x="502920" y="3044952"/>
+            <a:ext cx="8138160" cy="292608"/>
+          </a:xfrm>
+          <a:prstGeom prst="rect">
+            <a:avLst/>
+          </a:prstGeom>
+          <a:noFill/>
+        </p:spPr>
+        <p:txBody>
+          <a:bodyPr wrap="square">
+            <a:spAutoFit/>
+          </a:bodyPr>
+          <a:lstStyle/>
+          <a:p>
+            <a:pPr algn="r" rtl="1"/>
+            <a:r>
+              <a:rPr sz="1300" b="1">
+                <a:solidFill>
+                  <a:srgbClr val="B68A3A"/>
+                </a:solidFill>
+                <a:latin typeface="Amiri"/>
+              </a:rPr>
+              <a:t>السنة الرابعة: فرع شفا بدران</a:t>
+            </a:r>
+          </a:p>
+        </p:txBody>
+      </p:sp>
+      <p:sp>
+        <p:nvSpPr>
+          <p:cNvPr id="21" name="TextBox 20"/>
+          <p:cNvSpPr txBox="1"/>
+          <p:nvPr/>
+        </p:nvSpPr>
+        <p:spPr>
+          <a:xfrm>
+            <a:off x="502920" y="3337560"/>
+            <a:ext cx="8138160" cy="411480"/>
+          </a:xfrm>
+          <a:prstGeom prst="rect">
+            <a:avLst/>
+          </a:prstGeom>
+          <a:noFill/>
+        </p:spPr>
+        <p:txBody>
+          <a:bodyPr wrap="square">
+            <a:spAutoFit/>
+          </a:bodyPr>
+          <a:lstStyle/>
+          <a:p>
+            <a:pPr algn="r" rtl="1"/>
+            <a:r>
+              <a:rPr sz="1100" b="0">
+                <a:solidFill>
+                  <a:srgbClr val="232323"/>
+                </a:solidFill>
+                <a:latin typeface="Amiri"/>
+              </a:rPr>
+              <a:t>في حال نجاح فرع طريق المطار واستقرار المدرسة الأم، تستهدف الخطة افتتاح فرع في شفا بدران، مع توسيع البرامج الدولية وبناء إدارة مركزية مشتركة للموارد البشرية والجودة والتسويق والمالية.</a:t>
+            </a:r>
+          </a:p>
+        </p:txBody>
+      </p:sp>
+      <p:sp>
+        <p:nvSpPr>
+          <p:cNvPr id="22" name="TextBox 21"/>
+          <p:cNvSpPr txBox="1"/>
+          <p:nvPr/>
+        </p:nvSpPr>
+        <p:spPr>
+          <a:xfrm>
+            <a:off x="502920" y="3831336"/>
+            <a:ext cx="8138160" cy="292608"/>
+          </a:xfrm>
+          <a:prstGeom prst="rect">
+            <a:avLst/>
+          </a:prstGeom>
+          <a:noFill/>
+        </p:spPr>
+        <p:txBody>
+          <a:bodyPr wrap="square">
+            <a:spAutoFit/>
+          </a:bodyPr>
+          <a:lstStyle/>
+          <a:p>
+            <a:pPr algn="r" rtl="1"/>
+            <a:r>
+              <a:rPr sz="1300" b="1">
+                <a:solidFill>
+                  <a:srgbClr val="B68A3A"/>
+                </a:solidFill>
+                <a:latin typeface="Amiri"/>
+              </a:rPr>
+              <a:t>السنة الخامسة: بدء مرحلة الانتشار الفعلية</a:t>
+            </a:r>
+          </a:p>
+        </p:txBody>
+      </p:sp>
+      <p:sp>
+        <p:nvSpPr>
+          <p:cNvPr id="23" name="TextBox 22"/>
+          <p:cNvSpPr txBox="1"/>
+          <p:nvPr/>
+        </p:nvSpPr>
+        <p:spPr>
+          <a:xfrm>
+            <a:off x="502920" y="4123944"/>
+            <a:ext cx="8138160" cy="411480"/>
+          </a:xfrm>
+          <a:prstGeom prst="rect">
+            <a:avLst/>
+          </a:prstGeom>
+          <a:noFill/>
+        </p:spPr>
+        <p:txBody>
+          <a:bodyPr wrap="square">
+            <a:spAutoFit/>
+          </a:bodyPr>
+          <a:lstStyle/>
+          <a:p>
+            <a:pPr algn="r" rtl="1"/>
+            <a:r>
+              <a:rPr sz="1100" b="0">
+                <a:solidFill>
+                  <a:srgbClr val="232323"/>
+                </a:solidFill>
+                <a:latin typeface="Amiri"/>
+              </a:rPr>
+              <a:t>تبدأ المدرسة في السنة الخامسة مرحلة الانتشار المؤسسي الفعلي، من خلال اختيار مواقع إضافية داخل الأردن، أو بناء شراكات وفروع تعمل تحت اسم ونظام أكاديمي موحد، مع الحفاظ على الجودة وعدم التوسع أسرع من قدرة الإدارة على المتابعة.</a:t>
             </a:r>
           </a:p>
         </p:txBody>

</xml_diff>

<commit_message>
Fix red-bar Story artifacts and enforce Arabic RTL bullets.
PyMuPDF Story painted solid black/burgundy bars when color was set on
paragraphs/headings; colors now live on spans. Lists use manual RTL
bullets, and header-margin page-break leaks are scrubbed.

Co-authored-by: waseemabdelbaqi-lgtm <waseemabdelbaqi-lgtm@users.noreply.github.com>
</commit_message>
<xml_diff>
--- a/executive-edition/output/Lord_International_Program_Development_Plan_Executive.pptx
+++ b/executive-edition/output/Lord_International_Program_Development_Plan_Executive.pptx
@@ -4375,7 +4375,7 @@
                 </a:solidFill>
                 <a:latin typeface="Amiri"/>
               </a:rPr>
-              <a:t>• الأولوية للسنة الأولى والنتائج القابلة للقياس.</a:t>
+              <a:t>‏• الأولوية للسنة الأولى والنتائج القابلة للقياس.</a:t>
             </a:r>
           </a:p>
           <a:p>
@@ -4391,7 +4391,7 @@
                 </a:solidFill>
                 <a:latin typeface="Amiri"/>
               </a:rPr>
-              <a:t>• كل توسع لاحق مرتبط بتحقيق أهداف أكاديمية وتشغيلية ومالية واضحة.</a:t>
+              <a:t>‏• كل توسع لاحق مرتبط بتحقيق أهداف أكاديمية وتشغيلية ومالية واضحة.</a:t>
             </a:r>
           </a:p>
           <a:p>
@@ -4407,7 +4407,7 @@
                 </a:solidFill>
                 <a:latin typeface="Amiri"/>
               </a:rPr>
-              <a:t>• التطوير يتم بالتعاون مع إدارة المدرسة وضمن الميزانيات والصلاحيات المعتمدة.</a:t>
+              <a:t>‏• التطوير يتم بالتعاون مع إدارة المدرسة وضمن الميزانيات والصلاحيات المعتمدة.</a:t>
             </a:r>
           </a:p>
           <a:p>
@@ -4423,7 +4423,7 @@
                 </a:solidFill>
                 <a:latin typeface="Amiri"/>
               </a:rPr>
-              <a:t>• الأرقام الواردة تقديرية وتُحدَّث بعد الاطلاع على البيانات الرسمية.</a:t>
+              <a:t>‏• الأرقام الواردة تقديرية وتُحدَّث بعد الاطلاع على البيانات الرسمية.</a:t>
             </a:r>
           </a:p>
         </p:txBody>
@@ -5128,7 +5128,7 @@
                 </a:solidFill>
                 <a:latin typeface="Amiri"/>
               </a:rPr>
-              <a:t>• الطاقة الاستيعابية التقديرية: نحو 650 طالباً.</a:t>
+              <a:t>‏• الطاقة الاستيعابية التقديرية: نحو 650 طالباً.</a:t>
             </a:r>
           </a:p>
           <a:p>
@@ -5144,7 +5144,7 @@
                 </a:solidFill>
                 <a:latin typeface="Amiri"/>
               </a:rPr>
-              <a:t>• عدد الطلبة الحالي التقريبي: نحو 300 طالب، أي إشغال يقارب 46%.</a:t>
+              <a:t>‏• عدد الطلبة الحالي التقريبي: نحو 300 طالب، أي إشغال يقارب 46%.</a:t>
             </a:r>
           </a:p>
           <a:p>
@@ -5160,7 +5160,7 @@
                 </a:solidFill>
                 <a:latin typeface="Amiri"/>
               </a:rPr>
-              <a:t>• متوسط الرسوم السنوية التقديري: نحو 3,000 دينار للطالب، مع افتراض تحصيل فعلي يقارب 80%.</a:t>
+              <a:t>‏• متوسط الرسوم السنوية التقديري: نحو 3,000 دينار للطالب، مع افتراض تحصيل فعلي يقارب 80%.</a:t>
             </a:r>
           </a:p>
           <a:p>
@@ -5176,7 +5176,7 @@
                 </a:solidFill>
                 <a:latin typeface="Amiri"/>
               </a:rPr>
-              <a:t>• نحو 70% من الطلبة يستخدمون النقل المدرسي، ومتوسط الرسوم بين 200 و 300 دينار للفصل.</a:t>
+              <a:t>‏• نحو 70% من الطلبة يستخدمون النقل المدرسي، ومتوسط الرسوم بين 200 و 300 دينار للفصل.</a:t>
             </a:r>
           </a:p>
           <a:p>
@@ -5192,7 +5192,7 @@
                 </a:solidFill>
                 <a:latin typeface="Amiri"/>
               </a:rPr>
-              <a:t>• المدرسة تملك فرصة واضحة للنمو من خلال رفع جودة البرنامج الدولي، تحسين البيئة التعليمية، وتنفيذ تسويق متخصص.</a:t>
+              <a:t>‏• المدرسة تملك فرصة واضحة للنمو من خلال رفع جودة البرنامج الدولي، تحسين البيئة التعليمية، وتنفيذ تسويق متخصص.</a:t>
             </a:r>
           </a:p>
         </p:txBody>
@@ -5746,7 +5746,7 @@
                 </a:solidFill>
                 <a:latin typeface="Amiri"/>
               </a:rPr>
-              <a:t>• قدرة استيعابية جيدة تسمح بالنمو دون الحاجة الفورية إلى مبنى جديد.</a:t>
+              <a:t>‏• قدرة استيعابية جيدة تسمح بالنمو دون الحاجة الفورية إلى مبنى جديد.</a:t>
             </a:r>
           </a:p>
           <a:p>
@@ -5762,7 +5762,7 @@
                 </a:solidFill>
                 <a:latin typeface="Amiri"/>
               </a:rPr>
-              <a:t>• وجود مدرسة قائمة واسم يمكن البناء عليه بدلاً من البدء من الصفر.</a:t>
+              <a:t>‏• وجود مدرسة قائمة واسم يمكن البناء عليه بدلاً من البدء من الصفر.</a:t>
             </a:r>
           </a:p>
           <a:p>
@@ -5778,7 +5778,7 @@
                 </a:solidFill>
                 <a:latin typeface="Amiri"/>
               </a:rPr>
-              <a:t>• إمكانية تطوير البرنامج الدولي ليصبح عامل الجذب الأساسي للطلبة وأولياء الأمور.</a:t>
+              <a:t>‏• إمكانية تطوير البرنامج الدولي ليصبح عامل الجذب الأساسي للطلبة وأولياء الأمور.</a:t>
             </a:r>
           </a:p>
           <a:p>
@@ -5794,7 +5794,7 @@
                 </a:solidFill>
                 <a:latin typeface="Amiri"/>
               </a:rPr>
-              <a:t>• إمكانية إضافة برامج أجنبية جديدة وفق حاجة السوق واحتياجات الطلبة.</a:t>
+              <a:t>‏• إمكانية إضافة برامج أجنبية جديدة وفق حاجة السوق واحتياجات الطلبة.</a:t>
             </a:r>
           </a:p>
           <a:p>
@@ -5810,7 +5810,7 @@
                 </a:solidFill>
                 <a:latin typeface="Amiri"/>
               </a:rPr>
-              <a:t>• قابلية المدرسة للتحول إلى مركز للامتحانات الدولية بعد استيفاء المتطلبات الرسمية.</a:t>
+              <a:t>‏• قابلية المدرسة للتحول إلى مركز للامتحانات الدولية بعد استيفاء المتطلبات الرسمية.</a:t>
             </a:r>
           </a:p>
           <a:p>
@@ -5826,7 +5826,7 @@
                 </a:solidFill>
                 <a:latin typeface="Amiri"/>
               </a:rPr>
-              <a:t>• إمكانية التكامل مع شركة النجاح الأكيد ومنصتها التعليمية وخبراتها في البرامج الدولية.</a:t>
+              <a:t>‏• إمكانية التكامل مع شركة النجاح الأكيد ومنصتها التعليمية وخبراتها في البرامج الدولية.</a:t>
             </a:r>
           </a:p>
           <a:p>
@@ -5842,7 +5842,7 @@
                 </a:solidFill>
                 <a:latin typeface="Amiri"/>
               </a:rPr>
-              <a:t>• فرصة لتطوير علاقة قوية مع الجامعات المحلية والدولية وخدمات القبول والدراسة في الخارج.</a:t>
+              <a:t>‏• فرصة لتطوير علاقة قوية مع الجامعات المحلية والدولية وخدمات القبول والدراسة في الخارج.</a:t>
             </a:r>
           </a:p>
           <a:p>
@@ -5858,7 +5858,7 @@
                 </a:solidFill>
                 <a:latin typeface="Amiri"/>
               </a:rPr>
-              <a:t>• وجود مساحة نمو كبيرة في التسجيل، خصوصاً في الصفوف 10 و 11 و 12.</a:t>
+              <a:t>‏• وجود مساحة نمو كبيرة في التسجيل، خصوصاً في الصفوف 10 و 11 و 12.</a:t>
             </a:r>
           </a:p>
         </p:txBody>
@@ -6423,7 +6423,7 @@
                 </a:solidFill>
                 <a:latin typeface="Amiri"/>
               </a:rPr>
-              <a:t>• بعض الصفوف تحتاج إلى دهان وتجديد بصري يعطي انطباعاً تعليمياً أفضل.</a:t>
+              <a:t>‏• بعض الصفوف تحتاج إلى دهان وتجديد بصري يعطي انطباعاً تعليمياً أفضل.</a:t>
             </a:r>
           </a:p>
           <a:p>
@@ -6439,7 +6439,7 @@
                 </a:solidFill>
                 <a:latin typeface="Amiri"/>
               </a:rPr>
-              <a:t>• الحاجة إلى تركيب بلاط إسفنجي في الصفوف والمناطق التي تتطلب حماية إضافية.</a:t>
+              <a:t>‏• الحاجة إلى تركيب بلاط إسفنجي في الصفوف والمناطق التي تتطلب حماية إضافية.</a:t>
             </a:r>
           </a:p>
           <a:p>
@@ -6455,7 +6455,7 @@
                 </a:solidFill>
                 <a:latin typeface="Amiri"/>
               </a:rPr>
-              <a:t>• الحاجة إلى شاشات تعليمية حديثة وخزائن مناسبة داخل الصفوف.</a:t>
+              <a:t>‏• الحاجة إلى شاشات تعليمية حديثة وخزائن مناسبة داخل الصفوف.</a:t>
             </a:r>
           </a:p>
           <a:p>
@@ -6471,7 +6471,7 @@
                 </a:solidFill>
                 <a:latin typeface="Amiri"/>
               </a:rPr>
-              <a:t>• ضرورة تنظيم طريقة وضع الشاشة بجانب السبورة البيضاء حتى يتمكن المعلم من استخدام الوسيلتين معاً بكفاءة.</a:t>
+              <a:t>‏• ضرورة تنظيم طريقة وضع الشاشة بجانب السبورة البيضاء حتى يتمكن المعلم من استخدام الوسيلتين معاً بكفاءة.</a:t>
             </a:r>
           </a:p>
           <a:p>
@@ -6487,7 +6487,7 @@
                 </a:solidFill>
                 <a:latin typeface="Amiri"/>
               </a:rPr>
-              <a:t>• بعض الحمامات تحتاج إلى استكمال الأبواب وأعمال الصيانة الأساسية.</a:t>
+              <a:t>‏• بعض الحمامات تحتاج إلى استكمال الأبواب وأعمال الصيانة الأساسية.</a:t>
             </a:r>
           </a:p>
           <a:p>
@@ -6503,7 +6503,7 @@
                 </a:solidFill>
                 <a:latin typeface="Amiri"/>
               </a:rPr>
-              <a:t>• الحاجة إلى تعزيز السلامة على الدرج، خصوصاً الحواجز والإشارات ومناطق الحركة.</a:t>
+              <a:t>‏• الحاجة إلى تعزيز السلامة على الدرج، خصوصاً الحواجز والإشارات ومناطق الحركة.</a:t>
             </a:r>
           </a:p>
           <a:p>
@@ -6519,7 +6519,7 @@
                 </a:solidFill>
                 <a:latin typeface="Amiri"/>
               </a:rPr>
-              <a:t>• المختبرات تحتاج إلى تجهيز فعلي بالأدوات والمواد والأجهزة اللازمة للبرامج الدولية.</a:t>
+              <a:t>‏• المختبرات تحتاج إلى تجهيز فعلي بالأدوات والمواد والأجهزة اللازمة للبرامج الدولية.</a:t>
             </a:r>
           </a:p>
           <a:p>
@@ -6535,7 +6535,7 @@
                 </a:solidFill>
                 <a:latin typeface="Amiri"/>
               </a:rPr>
-              <a:t>• إعادة ترتيب الصفوف وتوزيعها حسب المراحل والبرامج لتقليل التشويش وتحسين الحركة.</a:t>
+              <a:t>‏• إعادة ترتيب الصفوف وتوزيعها حسب المراحل والبرامج لتقليل التشويش وتحسين الحركة.</a:t>
             </a:r>
           </a:p>
           <a:p>
@@ -6551,7 +6551,7 @@
                 </a:solidFill>
                 <a:latin typeface="Amiri"/>
               </a:rPr>
-              <a:t>• الحاجة إلى هوية واضحة للبرنامج الدولي وتسويق متخصص وليس تسويقاً عاماً فقط.</a:t>
+              <a:t>‏• الحاجة إلى هوية واضحة للبرنامج الدولي وتسويق متخصص وليس تسويقاً عاماً فقط.</a:t>
             </a:r>
           </a:p>
           <a:p>
@@ -6567,7 +6567,7 @@
                 </a:solidFill>
                 <a:latin typeface="Amiri"/>
               </a:rPr>
-              <a:t>• الحاجة إلى نظام ثابت لمتابعة المعلمين والطلبة والتواصل مع أولياء الأمور.</a:t>
+              <a:t>‏• الحاجة إلى نظام ثابت لمتابعة المعلمين والطلبة والتواصل مع أولياء الأمور.</a:t>
             </a:r>
           </a:p>
         </p:txBody>
@@ -7132,7 +7132,7 @@
                 </a:solidFill>
                 <a:latin typeface="Amiri"/>
               </a:rPr>
-              <a:t>• العمل على زيادة أعداد الطلبة في الصفوف 10 و 11 و 12 وما يتيسر من المراحل الأخرى.</a:t>
+              <a:t>‏• العمل على زيادة أعداد الطلبة في الصفوف 10 و 11 و 12 وما يتيسر من المراحل الأخرى.</a:t>
             </a:r>
           </a:p>
           <a:p>
@@ -7148,7 +7148,7 @@
                 </a:solidFill>
                 <a:latin typeface="Amiri"/>
               </a:rPr>
-              <a:t>• تطوير البرامج الأجنبية الحالية واقتراح برامج جديدة مناسبة للسوق.</a:t>
+              <a:t>‏• تطوير البرامج الأجنبية الحالية واقتراح برامج جديدة مناسبة للسوق.</a:t>
             </a:r>
           </a:p>
           <a:p>
@@ -7164,7 +7164,7 @@
                 </a:solidFill>
                 <a:latin typeface="Amiri"/>
               </a:rPr>
-              <a:t>• مراقبة أداء المعلمين بالتنسيق مع إدارة المدرسة، والتوصية بالتدريب أو الاستقطاب عند الحاجة.</a:t>
+              <a:t>‏• مراقبة أداء المعلمين بالتنسيق مع إدارة المدرسة، والتوصية بالتدريب أو الاستقطاب عند الحاجة.</a:t>
             </a:r>
           </a:p>
           <a:p>
@@ -7180,7 +7180,7 @@
                 </a:solidFill>
                 <a:latin typeface="Amiri"/>
               </a:rPr>
-              <a:t>• متابعة الطلبة فردياً، وتقييم احتياجاتهم، وإرشادهم إلى المواد والامتحانات الخارجية المناسبة.</a:t>
+              <a:t>‏• متابعة الطلبة فردياً، وتقييم احتياجاتهم، وإرشادهم إلى المواد والامتحانات الخارجية المناسبة.</a:t>
             </a:r>
           </a:p>
           <a:p>
@@ -7196,7 +7196,7 @@
                 </a:solidFill>
                 <a:latin typeface="Amiri"/>
               </a:rPr>
-              <a:t>• تنظيم تسجيل الطلبة في الامتحانات الدولية ومتابعة ملفاتهم الأكاديمية.</a:t>
+              <a:t>‏• تنظيم تسجيل الطلبة في الامتحانات الدولية ومتابعة ملفاتهم الأكاديمية.</a:t>
             </a:r>
           </a:p>
           <a:p>
@@ -7212,7 +7212,7 @@
                 </a:solidFill>
                 <a:latin typeface="Amiri"/>
               </a:rPr>
-              <a:t>• العمل التدريجي لجعل المدرسة مركزاً للامتحانات الدولية وفق المتطلبات والاعتمادات.</a:t>
+              <a:t>‏• العمل التدريجي لجعل المدرسة مركزاً للامتحانات الدولية وفق المتطلبات والاعتمادات.</a:t>
             </a:r>
           </a:p>
           <a:p>
@@ -7228,7 +7228,7 @@
                 </a:solidFill>
                 <a:latin typeface="Amiri"/>
               </a:rPr>
-              <a:t>• دمج خدمات مركز النجاح الأكيد والمنصة التعليمية بصورة تكاملية مع المدرسة.</a:t>
+              <a:t>‏• دمج خدمات مركز النجاح الأكيد والمنصة التعليمية بصورة تكاملية مع المدرسة.</a:t>
             </a:r>
           </a:p>
           <a:p>
@@ -7244,7 +7244,7 @@
                 </a:solidFill>
                 <a:latin typeface="Amiri"/>
               </a:rPr>
-              <a:t>• تنسيق الزيارات والفعاليات الجامعية، ودعم خدمات الدراسة في الخارج من خلال شركاء متخصصين.</a:t>
+              <a:t>‏• تنسيق الزيارات والفعاليات الجامعية، ودعم خدمات الدراسة في الخارج من خلال شركاء متخصصين.</a:t>
             </a:r>
           </a:p>
           <a:p>
@@ -7260,7 +7260,7 @@
                 </a:solidFill>
                 <a:latin typeface="Amiri"/>
               </a:rPr>
-              <a:t>• المساهمة في تدريس الفيزياء أو الكيمياء عند الحاجة، ودعم إعداد جداول المرحلة الثانوية.</a:t>
+              <a:t>‏• المساهمة في تدريس الفيزياء أو الكيمياء عند الحاجة، ودعم إعداد جداول المرحلة الثانوية.</a:t>
             </a:r>
           </a:p>
         </p:txBody>
@@ -9089,7 +9089,7 @@
                 </a:solidFill>
                 <a:latin typeface="Amiri"/>
               </a:rPr>
-              <a:t>• رفع عدد طلبة المدرسة تدريجياً من نحو 300 إلى هدف تقريبي يصل إلى 400-450 طالباً، مع مراجعة الهدف بعد الاطلاع على بيانات التسجيل الفعلية.</a:t>
+              <a:t>‏• رفع عدد طلبة المدرسة تدريجياً من نحو 300 إلى هدف تقريبي يصل إلى 400-450 طالباً، مع مراجعة الهدف بعد الاطلاع على بيانات التسجيل الفعلية.</a:t>
             </a:r>
           </a:p>
           <a:p>
@@ -9105,7 +9105,7 @@
                 </a:solidFill>
                 <a:latin typeface="Amiri"/>
               </a:rPr>
-              <a:t>• بناء برنامج دولي منظم له هوية واضحة وخدمة متابعة أكاديمية مميزة.</a:t>
+              <a:t>‏• بناء برنامج دولي منظم له هوية واضحة وخدمة متابعة أكاديمية مميزة.</a:t>
             </a:r>
           </a:p>
           <a:p>
@@ -9121,7 +9121,7 @@
                 </a:solidFill>
                 <a:latin typeface="Amiri"/>
               </a:rPr>
-              <a:t>• إنهاء أعمال السلامة والصيانة الأساسية ذات الأثر المباشر على الطلبة.</a:t>
+              <a:t>‏• إنهاء أعمال السلامة والصيانة الأساسية ذات الأثر المباشر على الطلبة.</a:t>
             </a:r>
           </a:p>
           <a:p>
@@ -9137,7 +9137,7 @@
                 </a:solidFill>
                 <a:latin typeface="Amiri"/>
               </a:rPr>
-              <a:t>• تجهيز مختبر واحد على الأقل بصورة كاملة كنموذج أولي، ثم استكمال بقية المختبرات حسب الأولوية والميزانية.</a:t>
+              <a:t>‏• تجهيز مختبر واحد على الأقل بصورة كاملة كنموذج أولي، ثم استكمال بقية المختبرات حسب الأولوية والميزانية.</a:t>
             </a:r>
           </a:p>
           <a:p>
@@ -9153,7 +9153,7 @@
                 </a:solidFill>
                 <a:latin typeface="Amiri"/>
               </a:rPr>
-              <a:t>• تطبيق نظام تقييم ومتابعة للمعلمين، وتقارير دورية للطلبة وأولياء الأمور.</a:t>
+              <a:t>‏• تطبيق نظام تقييم ومتابعة للمعلمين، وتقارير دورية للطلبة وأولياء الأمور.</a:t>
             </a:r>
           </a:p>
           <a:p>
@@ -9169,7 +9169,7 @@
                 </a:solidFill>
                 <a:latin typeface="Amiri"/>
               </a:rPr>
-              <a:t>• إطلاق تسويق تعليمي متخصص يركز على النتائج والخدمات والبرامج الدولية.</a:t>
+              <a:t>‏• إطلاق تسويق تعليمي متخصص يركز على النتائج والخدمات والبرامج الدولية.</a:t>
             </a:r>
           </a:p>
           <a:p>
@@ -9185,7 +9185,7 @@
                 </a:solidFill>
                 <a:latin typeface="Amiri"/>
               </a:rPr>
-              <a:t>• إعداد ملف الاعتماد أو مركز الامتحانات المناسب وبدء الخطوات الرسمية عند توفر الشروط.</a:t>
+              <a:t>‏• إعداد ملف الاعتماد أو مركز الامتحانات المناسب وبدء الخطوات الرسمية عند توفر الشروط.</a:t>
             </a:r>
           </a:p>
         </p:txBody>
@@ -9711,7 +9711,7 @@
                 </a:solidFill>
                 <a:latin typeface="Amiri"/>
               </a:rPr>
-              <a:t>• توسيع البرنامج الدولي وإضافة التخصصات والبرامج التي أثبتت وجود طلب عليها.</a:t>
+              <a:t>‏• توسيع البرنامج الدولي وإضافة التخصصات والبرامج التي أثبتت وجود طلب عليها.</a:t>
             </a:r>
           </a:p>
         </p:txBody>
@@ -9746,7 +9746,7 @@
                 </a:solidFill>
                 <a:latin typeface="Amiri"/>
               </a:rPr>
-              <a:t>• رفع الإشغال في المبنى الحالي، وتحسين الاستدامة المالية وجودة الخدمات.</a:t>
+              <a:t>‏• رفع الإشغال في المبنى الحالي، وتحسين الاستدامة المالية وجودة الخدمات.</a:t>
             </a:r>
           </a:p>
         </p:txBody>
@@ -9781,7 +9781,7 @@
                 </a:solidFill>
                 <a:latin typeface="Amiri"/>
               </a:rPr>
-              <a:t>• بناء فريق قيادة أكاديمية قادر على إدارة النمو دون الاعتماد على شخص واحد.</a:t>
+              <a:t>‏• بناء فريق قيادة أكاديمية قادر على إدارة النمو دون الاعتماد على شخص واحد.</a:t>
             </a:r>
           </a:p>
         </p:txBody>
@@ -9816,7 +9816,7 @@
                 </a:solidFill>
                 <a:latin typeface="Amiri"/>
               </a:rPr>
-              <a:t>• إعداد دراسة جدوى تفصيلية للفرع الثاني وتحديد الموقع والميزانية والنموذج التشغيلي.</a:t>
+              <a:t>‏• إعداد دراسة جدوى تفصيلية للفرع الثاني وتحديد الموقع والميزانية والنموذج التشغيلي.</a:t>
             </a:r>
           </a:p>
         </p:txBody>

</xml_diff>